<commit_message>
Release pass: retire superseded claims, add release checklist and claim index
Mark or correct statements superseded by the 2026-09-16 repository audit in
the decks, experiment pages, findings and citation metadata; index them in
docs/RETIRED_CLAIMS.md. Add docs/RELEASE.md (release checklist, venue
requirements checked 2026-09-16, open items), docs/release_manifest.py with
its test, and docs/paper/CLAIM_TO_EVIDENCE.md mapping each numeric claim in
the paper draft to its result file. Copy the repository audit into the tree
and regenerate both decks from the corrected source.
</commit_message>
<xml_diff>
--- a/docs/deck/ari-overview.pptx
+++ b/docs/deck/ari-overview.pptx
@@ -14,6 +14,7 @@
     <p:sldId id="262" r:id="rId13"/>
     <p:sldId id="263" r:id="rId14"/>
     <p:sldId id="264" r:id="rId15"/>
+    <p:sldId id="265" r:id="rId16"/>
   </p:sldIdLst>
   <p:sldSz cx="12191695" cy="6858000" type="screen4x3"/>
   <p:notesSz cx="6858000" cy="9144000"/>
@@ -3208,7 +3209,385 @@
                 </a:solidFill>
                 <a:latin typeface="Calibri"/>
               </a:rPr>
-              <a:t>Every number in this deck is read from a signed measurement. Verification instructions on the last slide.</a:t>
+              <a:t>Numbers are read from the experiment JSON in this repository. Slide 2 lists statements superseded by the 2026-09-16 audit.</a:t>
+            </a:r>
+          </a:p>
+        </p:txBody>
+      </p:sp>
+    </p:spTree>
+  </p:cSld>
+  <p:clrMapOvr>
+    <a:masterClrMapping/>
+  </p:clrMapOvr>
+</p:sld>
+</file>
+
+<file path=ppt/slides/slide10.xml><?xml version="1.0" encoding="utf-8"?>
+<p:sld xmlns:a="http://schemas.openxmlformats.org/drawingml/2006/main" xmlns:p="http://schemas.openxmlformats.org/presentationml/2006/main" xmlns:r="http://schemas.openxmlformats.org/officeDocument/2006/relationships">
+  <p:cSld>
+    <p:spTree>
+      <p:nvGrpSpPr>
+        <p:cNvPr id="1" name=""/>
+        <p:cNvGrpSpPr/>
+        <p:nvPr/>
+      </p:nvGrpSpPr>
+      <p:grpSpPr/>
+      <p:sp>
+        <p:nvSpPr>
+          <p:cNvPr id="2" name="TextBox 1"/>
+          <p:cNvSpPr txBox="1"/>
+          <p:nvPr/>
+        </p:nvSpPr>
+        <p:spPr>
+          <a:xfrm>
+            <a:off x="640080" y="320040"/>
+            <a:ext cx="10972800" cy="320040"/>
+          </a:xfrm>
+          <a:prstGeom prst="rect">
+            <a:avLst/>
+          </a:prstGeom>
+          <a:noFill/>
+        </p:spPr>
+        <p:txBody>
+          <a:bodyPr wrap="square">
+            <a:spAutoFit/>
+          </a:bodyPr>
+          <a:lstStyle/>
+          <a:p>
+            <a:pPr algn="l">
+              <a:spcAft>
+                <a:spcPts val="600"/>
+              </a:spcAft>
+            </a:pPr>
+            <a:r>
+              <a:rPr sz="1200" b="0">
+                <a:solidFill>
+                  <a:srgbClr val="6E6E6E"/>
+                </a:solidFill>
+                <a:latin typeface="Calibri"/>
+              </a:rPr>
+              <a:t>HONEST STATUS</a:t>
+            </a:r>
+          </a:p>
+        </p:txBody>
+      </p:sp>
+      <p:sp>
+        <p:nvSpPr>
+          <p:cNvPr id="3" name="TextBox 2"/>
+          <p:cNvSpPr txBox="1"/>
+          <p:nvPr/>
+        </p:nvSpPr>
+        <p:spPr>
+          <a:xfrm>
+            <a:off x="640080" y="640080"/>
+            <a:ext cx="10972800" cy="822960"/>
+          </a:xfrm>
+          <a:prstGeom prst="rect">
+            <a:avLst/>
+          </a:prstGeom>
+          <a:noFill/>
+        </p:spPr>
+        <p:txBody>
+          <a:bodyPr wrap="square">
+            <a:spAutoFit/>
+          </a:bodyPr>
+          <a:lstStyle/>
+          <a:p>
+            <a:pPr algn="l">
+              <a:spcAft>
+                <a:spcPts val="600"/>
+              </a:spcAft>
+            </a:pPr>
+            <a:r>
+              <a:rPr sz="2800" b="1">
+                <a:solidFill>
+                  <a:srgbClr val="1B1B1B"/>
+                </a:solidFill>
+                <a:latin typeface="Calibri"/>
+              </a:rPr>
+              <a:t>Where we actually are</a:t>
+            </a:r>
+          </a:p>
+        </p:txBody>
+      </p:sp>
+      <p:graphicFrame>
+        <p:nvGraphicFramePr>
+          <p:cNvPr id="4" name="Table 3"/>
+          <p:cNvGraphicFramePr>
+            <a:graphicFrameLocks noGrp="1"/>
+          </p:cNvGraphicFramePr>
+          <p:nvPr/>
+        </p:nvGraphicFramePr>
+        <p:xfrm>
+          <a:off x="822960" y="1828800"/>
+          <a:ext cx="10515600" cy="2743200"/>
+        </p:xfrm>
+        <a:graphic>
+          <a:graphicData uri="http://schemas.openxmlformats.org/drawingml/2006/table">
+            <a:tbl>
+              <a:tblPr firstRow="1" bandRow="1">
+                <a:tableStyleId>{5C22544A-7EE6-4342-B048-85BDC9FD1C3A}</a:tableStyleId>
+              </a:tblPr>
+              <a:tblGrid>
+                <a:gridCol w="3505200"/>
+                <a:gridCol w="3505200"/>
+                <a:gridCol w="3505200"/>
+              </a:tblGrid>
+              <a:tr h="685800">
+                <a:tc>
+                  <a:txBody>
+                    <a:bodyPr/>
+                    <a:lstStyle/>
+                    <a:p>
+                      <a:pPr algn="l"/>
+                      <a:r>
+                        <a:rPr sz="1500" b="1">
+                          <a:latin typeface="Calibri"/>
+                        </a:rPr>
+                        <a:t>Index</a:t>
+                      </a:r>
+                    </a:p>
+                  </a:txBody>
+                  <a:tcPr/>
+                </a:tc>
+                <a:tc>
+                  <a:txBody>
+                    <a:bodyPr/>
+                    <a:lstStyle/>
+                    <a:p>
+                      <a:pPr algn="r"/>
+                      <a:r>
+                        <a:rPr sz="1500" b="1">
+                          <a:latin typeface="Calibri"/>
+                        </a:rPr>
+                        <a:t>Status</a:t>
+                      </a:r>
+                    </a:p>
+                  </a:txBody>
+                  <a:tcPr/>
+                </a:tc>
+                <a:tc>
+                  <a:txBody>
+                    <a:bodyPr/>
+                    <a:lstStyle/>
+                    <a:p>
+                      <a:pPr algn="r"/>
+                      <a:r>
+                        <a:rPr sz="1500" b="1">
+                          <a:latin typeface="Calibri"/>
+                        </a:rPr>
+                        <a:t>Strength of the evidence</a:t>
+                      </a:r>
+                    </a:p>
+                  </a:txBody>
+                  <a:tcPr/>
+                </a:tc>
+              </a:tr>
+              <a:tr h="685800">
+                <a:tc>
+                  <a:txBody>
+                    <a:bodyPr/>
+                    <a:lstStyle/>
+                    <a:p>
+                      <a:pPr algn="l"/>
+                      <a:r>
+                        <a:rPr sz="1500" b="0">
+                          <a:latin typeface="Calibri"/>
+                        </a:rPr>
+                        <a:t>ARI-R</a:t>
+                      </a:r>
+                    </a:p>
+                  </a:txBody>
+                  <a:tcPr/>
+                </a:tc>
+                <a:tc>
+                  <a:txBody>
+                    <a:bodyPr/>
+                    <a:lstStyle/>
+                    <a:p>
+                      <a:pPr algn="r"/>
+                      <a:r>
+                        <a:rPr sz="1500" b="0">
+                          <a:latin typeface="Calibri"/>
+                        </a:rPr>
+                        <a:t>Measured on CPU and GPU</a:t>
+                      </a:r>
+                    </a:p>
+                  </a:txBody>
+                  <a:tcPr/>
+                </a:tc>
+                <a:tc>
+                  <a:txBody>
+                    <a:bodyPr/>
+                    <a:lstStyle/>
+                    <a:p>
+                      <a:pPr algn="r"/>
+                      <a:r>
+                        <a:rPr sz="1500" b="0">
+                          <a:latin typeface="Calibri"/>
+                        </a:rPr>
+                        <a:t>TF32 association replicated; attribution needs profiling</a:t>
+                      </a:r>
+                    </a:p>
+                  </a:txBody>
+                  <a:tcPr/>
+                </a:tc>
+              </a:tr>
+              <a:tr h="685800">
+                <a:tc>
+                  <a:txBody>
+                    <a:bodyPr/>
+                    <a:lstStyle/>
+                    <a:p>
+                      <a:pPr algn="l"/>
+                      <a:r>
+                        <a:rPr sz="1500" b="0">
+                          <a:latin typeface="Calibri"/>
+                        </a:rPr>
+                        <a:t>ARI-D</a:t>
+                      </a:r>
+                    </a:p>
+                  </a:txBody>
+                  <a:tcPr/>
+                </a:tc>
+                <a:tc>
+                  <a:txBody>
+                    <a:bodyPr/>
+                    <a:lstStyle/>
+                    <a:p>
+                      <a:pPr algn="r"/>
+                      <a:r>
+                        <a:rPr sz="1500" b="0">
+                          <a:latin typeface="Calibri"/>
+                        </a:rPr>
+                        <a:t>Measured on two models</a:t>
+                      </a:r>
+                    </a:p>
+                  </a:txBody>
+                  <a:tcPr/>
+                </a:tc>
+                <a:tc>
+                  <a:txBody>
+                    <a:bodyPr/>
+                    <a:lstStyle/>
+                    <a:p>
+                      <a:pPr algn="r"/>
+                      <a:r>
+                        <a:rPr sz="1500" b="0">
+                          <a:latin typeface="Calibri"/>
+                        </a:rPr>
+                        <a:t>Real, but a cheaper statistic competes</a:t>
+                      </a:r>
+                    </a:p>
+                  </a:txBody>
+                  <a:tcPr/>
+                </a:tc>
+              </a:tr>
+              <a:tr h="685800">
+                <a:tc>
+                  <a:txBody>
+                    <a:bodyPr/>
+                    <a:lstStyle/>
+                    <a:p>
+                      <a:pPr algn="l"/>
+                      <a:r>
+                        <a:rPr sz="1500" b="0">
+                          <a:latin typeface="Calibri"/>
+                        </a:rPr>
+                        <a:t>ARI-E</a:t>
+                      </a:r>
+                    </a:p>
+                  </a:txBody>
+                  <a:tcPr/>
+                </a:tc>
+                <a:tc>
+                  <a:txBody>
+                    <a:bodyPr/>
+                    <a:lstStyle/>
+                    <a:p>
+                      <a:pPr algn="r"/>
+                      <a:r>
+                        <a:rPr sz="1500" b="0">
+                          <a:latin typeface="Calibri"/>
+                        </a:rPr>
+                        <a:t>Historical analysis, withheld</a:t>
+                      </a:r>
+                    </a:p>
+                  </a:txBody>
+                  <a:tcPr/>
+                </a:tc>
+                <a:tc>
+                  <a:txBody>
+                    <a:bodyPr/>
+                    <a:lstStyle/>
+                    <a:p>
+                      <a:pPr algn="r"/>
+                      <a:r>
+                        <a:rPr sz="1500" b="0">
+                          <a:latin typeface="Calibri"/>
+                        </a:rPr>
+                        <a:t>Pending rerun with the corrected estimator</a:t>
+                      </a:r>
+                    </a:p>
+                  </a:txBody>
+                  <a:tcPr/>
+                </a:tc>
+              </a:tr>
+            </a:tbl>
+          </a:graphicData>
+        </a:graphic>
+      </p:graphicFrame>
+      <p:sp>
+        <p:nvSpPr>
+          <p:cNvPr id="5" name="TextBox 4"/>
+          <p:cNvSpPr txBox="1"/>
+          <p:nvPr/>
+        </p:nvSpPr>
+        <p:spPr>
+          <a:xfrm>
+            <a:off x="822960" y="4480560"/>
+            <a:ext cx="10607040" cy="4206240"/>
+          </a:xfrm>
+          <a:prstGeom prst="rect">
+            <a:avLst/>
+          </a:prstGeom>
+          <a:noFill/>
+        </p:spPr>
+        <p:txBody>
+          <a:bodyPr wrap="square">
+            <a:spAutoFit/>
+          </a:bodyPr>
+          <a:lstStyle/>
+          <a:p>
+            <a:pPr>
+              <a:spcAft>
+                <a:spcPts val="1200"/>
+              </a:spcAft>
+            </a:pPr>
+            <a:r>
+              <a:rPr sz="1500" b="1">
+                <a:solidFill>
+                  <a:srgbClr val="C1543A"/>
+                </a:solidFill>
+                <a:latin typeface="Calibri"/>
+              </a:rPr>
+              <a:t>Known weakness, stated up front: at the decoding layer a simple top-2 margin statistic gets 86% of the signal for a fraction of the storage.</a:t>
+            </a:r>
+          </a:p>
+          <a:p>
+            <a:pPr>
+              <a:spcAft>
+                <a:spcPts val="1200"/>
+              </a:spcAft>
+            </a:pPr>
+            <a:r>
+              <a:rPr sz="1500" b="0">
+                <a:solidFill>
+                  <a:srgbClr val="1B1B1B"/>
+                </a:solidFill>
+                <a:latin typeface="Calibri"/>
+              </a:rPr>
+              <a:t>What survives is coverage. It sees changes the cheap statistic is structurally blind to. The technical deck's tail-coverage slide has the evidence.</a:t>
             </a:r>
           </a:p>
         </p:txBody>
@@ -3265,7 +3644,7 @@
                 </a:solidFill>
                 <a:latin typeface="Calibri"/>
               </a:rPr>
-              <a:t>THE GAP</a:t>
+              <a:t>READ FIRST: 2026-09-16 REPOSITORY AUDIT</a:t>
             </a:r>
           </a:p>
         </p:txBody>
@@ -3304,7 +3683,7 @@
                 </a:solidFill>
                 <a:latin typeface="Calibri"/>
               </a:rPr>
-              <a:t>The problem: your dashboard cannot see the change</a:t>
+              <a:t>Superseded statements</a:t>
             </a:r>
           </a:p>
         </p:txBody>
@@ -3337,6 +3716,253 @@
               </a:spcAft>
             </a:pPr>
             <a:r>
+              <a:rPr sz="1400" b="1">
+                <a:solidFill>
+                  <a:srgbClr val="1B1B1B"/>
+                </a:solidFill>
+                <a:latin typeface="Calibri"/>
+              </a:rPr>
+              <a:t>This deck is a historical presentation artifact, regenerated from the experiment JSON on 2026-09-16. It is not maintained scientific evidence. Use the paper and docs/REPOSITORY_AUDIT.md for current claims.</a:t>
+            </a:r>
+          </a:p>
+          <a:p>
+            <a:pPr>
+              <a:spcAft>
+                <a:spcPts val="1200"/>
+              </a:spcAft>
+            </a:pPr>
+            <a:r>
+              <a:rPr sz="1400" b="0">
+                <a:solidFill>
+                  <a:srgbClr val="C1543A"/>
+                </a:solidFill>
+                <a:latin typeface="Calibri"/>
+              </a:rPr>
+              <a:t>ARI-E slides: the harness-effect numbers come from an earlier estimator and a partial trajectory export. The paper withholds them pending a rerun.</a:t>
+            </a:r>
+          </a:p>
+          <a:p>
+            <a:pPr>
+              <a:spcAft>
+                <a:spcPts val="1200"/>
+              </a:spcAft>
+            </a:pPr>
+            <a:r>
+              <a:rPr sz="1400" b="0">
+                <a:solidFill>
+                  <a:srgbClr val="C1543A"/>
+                </a:solidFill>
+                <a:latin typeface="Calibri"/>
+              </a:rPr>
+              <a:t>Self-hosted `time` cells were immediate repeats, not captures after a gap greater than 24 hours. The self-hosted comparable core is incomplete.</a:t>
+            </a:r>
+          </a:p>
+          <a:p>
+            <a:pPr>
+              <a:spcAft>
+                <a:spcPts val="1200"/>
+              </a:spcAft>
+            </a:pPr>
+            <a:r>
+              <a:rPr sz="1400" b="0">
+                <a:solidFill>
+                  <a:srgbClr val="1B1B1B"/>
+                </a:solidFill>
+                <a:latin typeface="Calibri"/>
+              </a:rPr>
+              <a:t>A nonsignificant Recall@10 difference is not equivalence. Ranked result lists did change under the same conditions.</a:t>
+            </a:r>
+          </a:p>
+          <a:p>
+            <a:pPr>
+              <a:spcAft>
+                <a:spcPts val="1200"/>
+              </a:spcAft>
+            </a:pPr>
+            <a:r>
+              <a:rPr sz="1400" b="0">
+                <a:solidFill>
+                  <a:srgbClr val="1B1B1B"/>
+                </a:solidFill>
+                <a:latin typeface="Calibri"/>
+              </a:rPr>
+              <a:t>'Early warning' means a changed code at a step whose token did not change. It is not a validated predictor of later failure.</a:t>
+            </a:r>
+          </a:p>
+          <a:p>
+            <a:pPr>
+              <a:spcAft>
+                <a:spcPts val="1200"/>
+              </a:spcAft>
+            </a:pPr>
+            <a:r>
+              <a:rPr sz="1400" b="0">
+                <a:solidFill>
+                  <a:srgbClr val="1B1B1B"/>
+                </a:solidFill>
+                <a:latin typeface="Calibri"/>
+              </a:rPr>
+              <a:t>TF32 and kernel-selection mechanism statements are consistent with the data but were not established by profiling.</a:t>
+            </a:r>
+          </a:p>
+          <a:p>
+            <a:pPr>
+              <a:spcAft>
+                <a:spcPts val="1200"/>
+              </a:spcAft>
+            </a:pPr>
+            <a:r>
+              <a:rPr sz="1400" b="0">
+                <a:solidFill>
+                  <a:srgbClr val="1B1B1B"/>
+                </a:solidFill>
+                <a:latin typeface="Calibri"/>
+              </a:rPr>
+              <a:t>Decoding disagreement rates labelled H-bar are packed-byte rates, not bit or coordinate rates.</a:t>
+            </a:r>
+          </a:p>
+          <a:p>
+            <a:pPr>
+              <a:spcAft>
+                <a:spcPts val="1200"/>
+              </a:spcAft>
+            </a:pPr>
+            <a:r>
+              <a:rPr sz="1400" b="0">
+                <a:solidFill>
+                  <a:srgbClr val="6E6E6E"/>
+                </a:solidFill>
+                <a:latin typeface="Calibri"/>
+              </a:rPr>
+              <a:t>Index of superseded statements: docs/RETIRED_CLAIMS.md.</a:t>
+            </a:r>
+          </a:p>
+        </p:txBody>
+      </p:sp>
+    </p:spTree>
+  </p:cSld>
+  <p:clrMapOvr>
+    <a:masterClrMapping/>
+  </p:clrMapOvr>
+</p:sld>
+</file>
+
+<file path=ppt/slides/slide3.xml><?xml version="1.0" encoding="utf-8"?>
+<p:sld xmlns:a="http://schemas.openxmlformats.org/drawingml/2006/main" xmlns:p="http://schemas.openxmlformats.org/presentationml/2006/main" xmlns:r="http://schemas.openxmlformats.org/officeDocument/2006/relationships">
+  <p:cSld>
+    <p:spTree>
+      <p:nvGrpSpPr>
+        <p:cNvPr id="1" name=""/>
+        <p:cNvGrpSpPr/>
+        <p:nvPr/>
+      </p:nvGrpSpPr>
+      <p:grpSpPr/>
+      <p:sp>
+        <p:nvSpPr>
+          <p:cNvPr id="2" name="TextBox 1"/>
+          <p:cNvSpPr txBox="1"/>
+          <p:nvPr/>
+        </p:nvSpPr>
+        <p:spPr>
+          <a:xfrm>
+            <a:off x="640080" y="320040"/>
+            <a:ext cx="10972800" cy="320040"/>
+          </a:xfrm>
+          <a:prstGeom prst="rect">
+            <a:avLst/>
+          </a:prstGeom>
+          <a:noFill/>
+        </p:spPr>
+        <p:txBody>
+          <a:bodyPr wrap="square">
+            <a:spAutoFit/>
+          </a:bodyPr>
+          <a:lstStyle/>
+          <a:p>
+            <a:pPr algn="l">
+              <a:spcAft>
+                <a:spcPts val="600"/>
+              </a:spcAft>
+            </a:pPr>
+            <a:r>
+              <a:rPr sz="1200" b="0">
+                <a:solidFill>
+                  <a:srgbClr val="6E6E6E"/>
+                </a:solidFill>
+                <a:latin typeface="Calibri"/>
+              </a:rPr>
+              <a:t>THE GAP</a:t>
+            </a:r>
+          </a:p>
+        </p:txBody>
+      </p:sp>
+      <p:sp>
+        <p:nvSpPr>
+          <p:cNvPr id="3" name="TextBox 2"/>
+          <p:cNvSpPr txBox="1"/>
+          <p:nvPr/>
+        </p:nvSpPr>
+        <p:spPr>
+          <a:xfrm>
+            <a:off x="640080" y="640080"/>
+            <a:ext cx="10972800" cy="822960"/>
+          </a:xfrm>
+          <a:prstGeom prst="rect">
+            <a:avLst/>
+          </a:prstGeom>
+          <a:noFill/>
+        </p:spPr>
+        <p:txBody>
+          <a:bodyPr wrap="square">
+            <a:spAutoFit/>
+          </a:bodyPr>
+          <a:lstStyle/>
+          <a:p>
+            <a:pPr algn="l">
+              <a:spcAft>
+                <a:spcPts val="600"/>
+              </a:spcAft>
+            </a:pPr>
+            <a:r>
+              <a:rPr sz="2800" b="1">
+                <a:solidFill>
+                  <a:srgbClr val="1B1B1B"/>
+                </a:solidFill>
+                <a:latin typeface="Calibri"/>
+              </a:rPr>
+              <a:t>The problem: your dashboard cannot see the change</a:t>
+            </a:r>
+          </a:p>
+        </p:txBody>
+      </p:sp>
+      <p:sp>
+        <p:nvSpPr>
+          <p:cNvPr id="4" name="TextBox 3"/>
+          <p:cNvSpPr txBox="1"/>
+          <p:nvPr/>
+        </p:nvSpPr>
+        <p:spPr>
+          <a:xfrm>
+            <a:off x="822960" y="1737360"/>
+            <a:ext cx="10607040" cy="4206240"/>
+          </a:xfrm>
+          <a:prstGeom prst="rect">
+            <a:avLst/>
+          </a:prstGeom>
+          <a:noFill/>
+        </p:spPr>
+        <p:txBody>
+          <a:bodyPr wrap="square">
+            <a:spAutoFit/>
+          </a:bodyPr>
+          <a:lstStyle/>
+          <a:p>
+            <a:pPr>
+              <a:spcAft>
+                <a:spcPts val="1200"/>
+              </a:spcAft>
+            </a:pPr>
+            <a:r>
               <a:rPr sz="1700" b="1">
                 <a:solidFill>
                   <a:srgbClr val="1B1B1B"/>
@@ -3459,7 +4085,7 @@
 </p:sld>
 </file>
 
-<file path=ppt/slides/slide3.xml><?xml version="1.0" encoding="utf-8"?>
+<file path=ppt/slides/slide4.xml><?xml version="1.0" encoding="utf-8"?>
 <p:sld xmlns:a="http://schemas.openxmlformats.org/drawingml/2006/main" xmlns:p="http://schemas.openxmlformats.org/presentationml/2006/main" xmlns:r="http://schemas.openxmlformats.org/officeDocument/2006/relationships">
   <p:cSld>
     <p:spTree>
@@ -3837,7 +4463,7 @@
 </p:sld>
 </file>
 
-<file path=ppt/slides/slide4.xml><?xml version="1.0" encoding="utf-8"?>
+<file path=ppt/slides/slide5.xml><?xml version="1.0" encoding="utf-8"?>
 <p:sld xmlns:a="http://schemas.openxmlformats.org/drawingml/2006/main" xmlns:p="http://schemas.openxmlformats.org/presentationml/2006/main" xmlns:r="http://schemas.openxmlformats.org/officeDocument/2006/relationships">
   <p:cSld>
     <p:spTree>
@@ -4200,7 +4826,7 @@
                 </a:solidFill>
                 <a:latin typeface="Calibri"/>
               </a:rPr>
-              <a:t>The audited system and the served system disagree on 47% of documents. Retrieval quality moves by exactly zero. Turning TF32 off restores agreement, which is what attributes the effect to that one switch.</a:t>
+              <a:t>The audited system and the served system disagree on 47% of documents. No Recall@10 change was detected; a nonsignificant difference is not equivalence. Turning TF32 off restores agreement, which associates the effect with that one switch.</a:t>
             </a:r>
           </a:p>
         </p:txBody>
@@ -4213,7 +4839,7 @@
 </p:sld>
 </file>
 
-<file path=ppt/slides/slide5.xml><?xml version="1.0" encoding="utf-8"?>
+<file path=ppt/slides/slide6.xml><?xml version="1.0" encoding="utf-8"?>
 <p:sld xmlns:a="http://schemas.openxmlformats.org/drawingml/2006/main" xmlns:p="http://schemas.openxmlformats.org/presentationml/2006/main" xmlns:r="http://schemas.openxmlformats.org/officeDocument/2006/relationships">
   <p:cSld>
     <p:spTree>
@@ -4542,7 +5168,7 @@
                 </a:solidFill>
                 <a:latin typeface="Calibri"/>
               </a:rPr>
-              <a:t>Output comparison is silent across the entire run. The instrument reads the change at every step. That is the difference between finding out now and finding out from a customer.</a:t>
+              <a:t>Output comparison is silent across the entire run. The instrument reads a code change at every step while the token is unchanged. This is contemporaneous disagreement, not a validated predictor of later failure.</a:t>
             </a:r>
           </a:p>
         </p:txBody>
@@ -4555,7 +5181,7 @@
 </p:sld>
 </file>
 
-<file path=ppt/slides/slide6.xml><?xml version="1.0" encoding="utf-8"?>
+<file path=ppt/slides/slide7.xml><?xml version="1.0" encoding="utf-8"?>
 <p:sld xmlns:a="http://schemas.openxmlformats.org/drawingml/2006/main" xmlns:p="http://schemas.openxmlformats.org/presentationml/2006/main" xmlns:r="http://schemas.openxmlformats.org/officeDocument/2006/relationships">
   <p:cSld>
     <p:spTree>
@@ -4599,7 +5225,7 @@
                 </a:solidFill>
                 <a:latin typeface="Calibri"/>
               </a:rPr>
-              <a:t>USE CASE 3</a:t>
+              <a:t>USE CASE 3. HISTORICAL: WITHHELD FROM THE PAPER PENDING RERUN</a:t>
             </a:r>
           </a:p>
         </p:txBody>
@@ -4862,11 +5488,11 @@
             <a:r>
               <a:rPr sz="1500" b="0">
                 <a:solidFill>
-                  <a:srgbClr val="1B1B1B"/>
+                  <a:srgbClr val="C1543A"/>
                 </a:solidFill>
                 <a:latin typeface="Calibri"/>
               </a:rPr>
-              <a:t>The wrapper mattered more than the model. Benchmark tables that name only the model are not comparable.</a:t>
+              <a:t>Historical reading: the wrapper effect exceeded the model effect for these pairs. Superseded: earlier estimator, partial export; not a current result.</a:t>
             </a:r>
           </a:p>
         </p:txBody>
@@ -4879,7 +5505,7 @@
 </p:sld>
 </file>
 
-<file path=ppt/slides/slide7.xml><?xml version="1.0" encoding="utf-8"?>
+<file path=ppt/slides/slide8.xml><?xml version="1.0" encoding="utf-8"?>
 <p:sld xmlns:a="http://schemas.openxmlformats.org/drawingml/2006/main" xmlns:p="http://schemas.openxmlformats.org/presentationml/2006/main" xmlns:r="http://schemas.openxmlformats.org/officeDocument/2006/relationships">
   <p:cSld>
     <p:spTree>
@@ -4923,7 +5549,7 @@
                 </a:solidFill>
                 <a:latin typeface="Calibri"/>
               </a:rPr>
-              <a:t>WHY THIS IS HARD TO COPY</a:t>
+              <a:t>WHY THIS IS HARD TO COPY. HISTORICAL NUMBERS, SEE SLIDE 2</a:t>
             </a:r>
           </a:p>
         </p:txBody>
@@ -5196,229 +5822,7 @@
                 </a:solidFill>
                 <a:latin typeface="Calibri"/>
               </a:rPr>
-              <a:t>The naive number is 2.4x too large. Across every comparison we ran, the control removed 59-74% of the apparent effect. A competitor without it reports noise as signal.</a:t>
-            </a:r>
-          </a:p>
-        </p:txBody>
-      </p:sp>
-    </p:spTree>
-  </p:cSld>
-  <p:clrMapOvr>
-    <a:masterClrMapping/>
-  </p:clrMapOvr>
-</p:sld>
-</file>
-
-<file path=ppt/slides/slide8.xml><?xml version="1.0" encoding="utf-8"?>
-<p:sld xmlns:a="http://schemas.openxmlformats.org/drawingml/2006/main" xmlns:p="http://schemas.openxmlformats.org/presentationml/2006/main" xmlns:r="http://schemas.openxmlformats.org/officeDocument/2006/relationships">
-  <p:cSld>
-    <p:spTree>
-      <p:nvGrpSpPr>
-        <p:cNvPr id="1" name=""/>
-        <p:cNvGrpSpPr/>
-        <p:nvPr/>
-      </p:nvGrpSpPr>
-      <p:grpSpPr/>
-      <p:sp>
-        <p:nvSpPr>
-          <p:cNvPr id="2" name="TextBox 1"/>
-          <p:cNvSpPr txBox="1"/>
-          <p:nvPr/>
-        </p:nvSpPr>
-        <p:spPr>
-          <a:xfrm>
-            <a:off x="640080" y="320040"/>
-            <a:ext cx="10972800" cy="320040"/>
-          </a:xfrm>
-          <a:prstGeom prst="rect">
-            <a:avLst/>
-          </a:prstGeom>
-          <a:noFill/>
-        </p:spPr>
-        <p:txBody>
-          <a:bodyPr wrap="square">
-            <a:spAutoFit/>
-          </a:bodyPr>
-          <a:lstStyle/>
-          <a:p>
-            <a:pPr algn="l">
-              <a:spcAft>
-                <a:spcPts val="600"/>
-              </a:spcAft>
-            </a:pPr>
-            <a:r>
-              <a:rPr sz="1200" b="0">
-                <a:solidFill>
-                  <a:srgbClr val="6E6E6E"/>
-                </a:solidFill>
-                <a:latin typeface="Calibri"/>
-              </a:rPr>
-              <a:t>WHY IT IS CREDIBLE</a:t>
-            </a:r>
-          </a:p>
-        </p:txBody>
-      </p:sp>
-      <p:sp>
-        <p:nvSpPr>
-          <p:cNvPr id="3" name="TextBox 2"/>
-          <p:cNvSpPr txBox="1"/>
-          <p:nvPr/>
-        </p:nvSpPr>
-        <p:spPr>
-          <a:xfrm>
-            <a:off x="640080" y="640080"/>
-            <a:ext cx="10972800" cy="822960"/>
-          </a:xfrm>
-          <a:prstGeom prst="rect">
-            <a:avLst/>
-          </a:prstGeom>
-          <a:noFill/>
-        </p:spPr>
-        <p:txBody>
-          <a:bodyPr wrap="square">
-            <a:spAutoFit/>
-          </a:bodyPr>
-          <a:lstStyle/>
-          <a:p>
-            <a:pPr algn="l">
-              <a:spcAft>
-                <a:spcPts val="600"/>
-              </a:spcAft>
-            </a:pPr>
-            <a:r>
-              <a:rPr sz="2800" b="1">
-                <a:solidFill>
-                  <a:srgbClr val="1B1B1B"/>
-                </a:solidFill>
-                <a:latin typeface="Calibri"/>
-              </a:rPr>
-              <a:t>Anyone can check our numbers without trusting us</a:t>
-            </a:r>
-          </a:p>
-        </p:txBody>
-      </p:sp>
-      <p:sp>
-        <p:nvSpPr>
-          <p:cNvPr id="4" name="TextBox 3"/>
-          <p:cNvSpPr txBox="1"/>
-          <p:nvPr/>
-        </p:nvSpPr>
-        <p:spPr>
-          <a:xfrm>
-            <a:off x="822960" y="1737360"/>
-            <a:ext cx="10607040" cy="4206240"/>
-          </a:xfrm>
-          <a:prstGeom prst="rect">
-            <a:avLst/>
-          </a:prstGeom>
-          <a:noFill/>
-        </p:spPr>
-        <p:txBody>
-          <a:bodyPr wrap="square">
-            <a:spAutoFit/>
-          </a:bodyPr>
-          <a:lstStyle/>
-          <a:p>
-            <a:pPr>
-              <a:spcAft>
-                <a:spcPts val="1200"/>
-              </a:spcAft>
-            </a:pPr>
-            <a:r>
-              <a:rPr sz="1700" b="1">
-                <a:solidFill>
-                  <a:srgbClr val="1B1B1B"/>
-                </a:solidFill>
-                <a:latin typeface="Calibri"/>
-              </a:rPr>
-              <a:t>Every report is cryptographically signed and bound to the exact data it came from.</a:t>
-            </a:r>
-          </a:p>
-          <a:p>
-            <a:pPr>
-              <a:spcAft>
-                <a:spcPts val="1200"/>
-              </a:spcAft>
-            </a:pPr>
-            <a:r>
-              <a:rPr sz="1700" b="0">
-                <a:solidFill>
-                  <a:srgbClr val="1B1B1B"/>
-                </a:solidFill>
-                <a:latin typeface="Calibri"/>
-              </a:rPr>
-              <a:t>Change the report, or the data underneath it, and verification fails.</a:t>
-            </a:r>
-          </a:p>
-          <a:p>
-            <a:pPr>
-              <a:spcAft>
-                <a:spcPts val="1200"/>
-              </a:spcAft>
-            </a:pPr>
-            <a:r>
-              <a:rPr sz="1700" b="1">
-                <a:solidFill>
-                  <a:srgbClr val="0B6E4F"/>
-                </a:solidFill>
-                <a:latin typeface="Calibri"/>
-              </a:rPr>
-              <a:t>The verifier is 175 lines and does not use our software.</a:t>
-            </a:r>
-          </a:p>
-          <a:p>
-            <a:pPr>
-              <a:spcAft>
-                <a:spcPts val="1200"/>
-              </a:spcAft>
-            </a:pPr>
-            <a:r>
-              <a:rPr sz="1700" b="0">
-                <a:solidFill>
-                  <a:srgbClr val="1B1B1B"/>
-                </a:solidFill>
-                <a:latin typeface="Calibri"/>
-              </a:rPr>
-              <a:t>A standard whose verification requires the vendor's code is not a standard.</a:t>
-            </a:r>
-          </a:p>
-        </p:txBody>
-      </p:sp>
-      <p:sp>
-        <p:nvSpPr>
-          <p:cNvPr id="5" name="TextBox 4"/>
-          <p:cNvSpPr txBox="1"/>
-          <p:nvPr/>
-        </p:nvSpPr>
-        <p:spPr>
-          <a:xfrm>
-            <a:off x="640080" y="5120640"/>
-            <a:ext cx="10972800" cy="548640"/>
-          </a:xfrm>
-          <a:prstGeom prst="rect">
-            <a:avLst/>
-          </a:prstGeom>
-          <a:noFill/>
-        </p:spPr>
-        <p:txBody>
-          <a:bodyPr wrap="square">
-            <a:spAutoFit/>
-          </a:bodyPr>
-          <a:lstStyle/>
-          <a:p>
-            <a:pPr algn="l">
-              <a:spcAft>
-                <a:spcPts val="600"/>
-              </a:spcAft>
-            </a:pPr>
-            <a:r>
-              <a:rPr sz="1400" b="0">
-                <a:solidFill>
-                  <a:srgbClr val="0B6E4F"/>
-                </a:solidFill>
-                <a:latin typeface="Calibri"/>
-              </a:rPr>
-              <a:t>python verify_report.py harness_effect.json --expect-key &lt;key&gt;   -&gt;   ALL CHECKS PASSED</a:t>
+              <a:t>In the historical run the control removed 59-74% of the apparent effect. The estimator has since been corrected and the numbers await a rerun; the method point stands, the values do not.</a:t>
             </a:r>
           </a:p>
         </p:txBody>
@@ -5475,7 +5879,7 @@
                 </a:solidFill>
                 <a:latin typeface="Calibri"/>
               </a:rPr>
-              <a:t>HONEST STATUS</a:t>
+              <a:t>WHY IT IS CREDIBLE</a:t>
             </a:r>
           </a:p>
         </p:txBody>
@@ -5514,247 +5918,20 @@
                 </a:solidFill>
                 <a:latin typeface="Calibri"/>
               </a:rPr>
-              <a:t>Where we actually are</a:t>
-            </a:r>
-          </a:p>
-        </p:txBody>
-      </p:sp>
-      <p:graphicFrame>
-        <p:nvGraphicFramePr>
-          <p:cNvPr id="4" name="Table 3"/>
-          <p:cNvGraphicFramePr>
-            <a:graphicFrameLocks noGrp="1"/>
-          </p:cNvGraphicFramePr>
-          <p:nvPr/>
-        </p:nvGraphicFramePr>
-        <p:xfrm>
-          <a:off x="822960" y="1828800"/>
-          <a:ext cx="10515600" cy="2743200"/>
-        </p:xfrm>
-        <a:graphic>
-          <a:graphicData uri="http://schemas.openxmlformats.org/drawingml/2006/table">
-            <a:tbl>
-              <a:tblPr firstRow="1" bandRow="1">
-                <a:tableStyleId>{5C22544A-7EE6-4342-B048-85BDC9FD1C3A}</a:tableStyleId>
-              </a:tblPr>
-              <a:tblGrid>
-                <a:gridCol w="3505200"/>
-                <a:gridCol w="3505200"/>
-                <a:gridCol w="3505200"/>
-              </a:tblGrid>
-              <a:tr h="685800">
-                <a:tc>
-                  <a:txBody>
-                    <a:bodyPr/>
-                    <a:lstStyle/>
-                    <a:p>
-                      <a:pPr algn="l"/>
-                      <a:r>
-                        <a:rPr sz="1500" b="1">
-                          <a:latin typeface="Calibri"/>
-                        </a:rPr>
-                        <a:t>Index</a:t>
-                      </a:r>
-                    </a:p>
-                  </a:txBody>
-                  <a:tcPr/>
-                </a:tc>
-                <a:tc>
-                  <a:txBody>
-                    <a:bodyPr/>
-                    <a:lstStyle/>
-                    <a:p>
-                      <a:pPr algn="r"/>
-                      <a:r>
-                        <a:rPr sz="1500" b="1">
-                          <a:latin typeface="Calibri"/>
-                        </a:rPr>
-                        <a:t>Status</a:t>
-                      </a:r>
-                    </a:p>
-                  </a:txBody>
-                  <a:tcPr/>
-                </a:tc>
-                <a:tc>
-                  <a:txBody>
-                    <a:bodyPr/>
-                    <a:lstStyle/>
-                    <a:p>
-                      <a:pPr algn="r"/>
-                      <a:r>
-                        <a:rPr sz="1500" b="1">
-                          <a:latin typeface="Calibri"/>
-                        </a:rPr>
-                        <a:t>Strength of the evidence</a:t>
-                      </a:r>
-                    </a:p>
-                  </a:txBody>
-                  <a:tcPr/>
-                </a:tc>
-              </a:tr>
-              <a:tr h="685800">
-                <a:tc>
-                  <a:txBody>
-                    <a:bodyPr/>
-                    <a:lstStyle/>
-                    <a:p>
-                      <a:pPr algn="l"/>
-                      <a:r>
-                        <a:rPr sz="1500" b="0">
-                          <a:latin typeface="Calibri"/>
-                        </a:rPr>
-                        <a:t>ARI-R</a:t>
-                      </a:r>
-                    </a:p>
-                  </a:txBody>
-                  <a:tcPr/>
-                </a:tc>
-                <a:tc>
-                  <a:txBody>
-                    <a:bodyPr/>
-                    <a:lstStyle/>
-                    <a:p>
-                      <a:pPr algn="r"/>
-                      <a:r>
-                        <a:rPr sz="1500" b="0">
-                          <a:latin typeface="Calibri"/>
-                        </a:rPr>
-                        <a:t>Measured on CPU and GPU</a:t>
-                      </a:r>
-                    </a:p>
-                  </a:txBody>
-                  <a:tcPr/>
-                </a:tc>
-                <a:tc>
-                  <a:txBody>
-                    <a:bodyPr/>
-                    <a:lstStyle/>
-                    <a:p>
-                      <a:pPr algn="r"/>
-                      <a:r>
-                        <a:rPr sz="1500" b="0">
-                          <a:latin typeface="Calibri"/>
-                        </a:rPr>
-                        <a:t>Strong. The TF32 result is clean</a:t>
-                      </a:r>
-                    </a:p>
-                  </a:txBody>
-                  <a:tcPr/>
-                </a:tc>
-              </a:tr>
-              <a:tr h="685800">
-                <a:tc>
-                  <a:txBody>
-                    <a:bodyPr/>
-                    <a:lstStyle/>
-                    <a:p>
-                      <a:pPr algn="l"/>
-                      <a:r>
-                        <a:rPr sz="1500" b="0">
-                          <a:latin typeface="Calibri"/>
-                        </a:rPr>
-                        <a:t>ARI-D</a:t>
-                      </a:r>
-                    </a:p>
-                  </a:txBody>
-                  <a:tcPr/>
-                </a:tc>
-                <a:tc>
-                  <a:txBody>
-                    <a:bodyPr/>
-                    <a:lstStyle/>
-                    <a:p>
-                      <a:pPr algn="r"/>
-                      <a:r>
-                        <a:rPr sz="1500" b="0">
-                          <a:latin typeface="Calibri"/>
-                        </a:rPr>
-                        <a:t>Measured on two models</a:t>
-                      </a:r>
-                    </a:p>
-                  </a:txBody>
-                  <a:tcPr/>
-                </a:tc>
-                <a:tc>
-                  <a:txBody>
-                    <a:bodyPr/>
-                    <a:lstStyle/>
-                    <a:p>
-                      <a:pPr algn="r"/>
-                      <a:r>
-                        <a:rPr sz="1500" b="0">
-                          <a:latin typeface="Calibri"/>
-                        </a:rPr>
-                        <a:t>Real, but a cheaper statistic competes</a:t>
-                      </a:r>
-                    </a:p>
-                  </a:txBody>
-                  <a:tcPr/>
-                </a:tc>
-              </a:tr>
-              <a:tr h="685800">
-                <a:tc>
-                  <a:txBody>
-                    <a:bodyPr/>
-                    <a:lstStyle/>
-                    <a:p>
-                      <a:pPr algn="l"/>
-                      <a:r>
-                        <a:rPr sz="1500" b="0">
-                          <a:latin typeface="Calibri"/>
-                        </a:rPr>
-                        <a:t>ARI-E</a:t>
-                      </a:r>
-                    </a:p>
-                  </a:txBody>
-                  <a:tcPr/>
-                </a:tc>
-                <a:tc>
-                  <a:txBody>
-                    <a:bodyPr/>
-                    <a:lstStyle/>
-                    <a:p>
-                      <a:pPr algn="r"/>
-                      <a:r>
-                        <a:rPr sz="1500" b="0">
-                          <a:latin typeface="Calibri"/>
-                        </a:rPr>
-                        <a:t>22,000 real agent runs</a:t>
-                      </a:r>
-                    </a:p>
-                  </a:txBody>
-                  <a:tcPr/>
-                </a:tc>
-                <a:tc>
-                  <a:txBody>
-                    <a:bodyPr/>
-                    <a:lstStyle/>
-                    <a:p>
-                      <a:pPr algn="r"/>
-                      <a:r>
-                        <a:rPr sz="1500" b="0">
-                          <a:latin typeface="Calibri"/>
-                        </a:rPr>
-                        <a:t>Strong. Largest effect of the three</a:t>
-                      </a:r>
-                    </a:p>
-                  </a:txBody>
-                  <a:tcPr/>
-                </a:tc>
-              </a:tr>
-            </a:tbl>
-          </a:graphicData>
-        </a:graphic>
-      </p:graphicFrame>
-      <p:sp>
-        <p:nvSpPr>
-          <p:cNvPr id="5" name="TextBox 4"/>
+              <a:t>Anyone can check our numbers without trusting us</a:t>
+            </a:r>
+          </a:p>
+        </p:txBody>
+      </p:sp>
+      <p:sp>
+        <p:nvSpPr>
+          <p:cNvPr id="4" name="TextBox 3"/>
           <p:cNvSpPr txBox="1"/>
           <p:nvPr/>
         </p:nvSpPr>
         <p:spPr>
           <a:xfrm>
-            <a:off x="822960" y="4480560"/>
+            <a:off x="822960" y="1737360"/>
             <a:ext cx="10607040" cy="4206240"/>
           </a:xfrm>
           <a:prstGeom prst="rect">
@@ -5774,13 +5951,13 @@
               </a:spcAft>
             </a:pPr>
             <a:r>
-              <a:rPr sz="1500" b="1">
-                <a:solidFill>
-                  <a:srgbClr val="C1543A"/>
+              <a:rPr sz="1700" b="1">
+                <a:solidFill>
+                  <a:srgbClr val="1B1B1B"/>
                 </a:solidFill>
                 <a:latin typeface="Calibri"/>
               </a:rPr>
-              <a:t>Known weakness, stated up front: at the decoding layer a simple top-2 margin statistic gets 86% of the signal for a fraction of the storage.</a:t>
+              <a:t>Every report is cryptographically signed and bound to the exact data it came from.</a:t>
             </a:r>
           </a:p>
           <a:p>
@@ -5790,13 +5967,84 @@
               </a:spcAft>
             </a:pPr>
             <a:r>
-              <a:rPr sz="1500" b="0">
+              <a:rPr sz="1700" b="0">
                 <a:solidFill>
                   <a:srgbClr val="1B1B1B"/>
                 </a:solidFill>
                 <a:latin typeface="Calibri"/>
               </a:rPr>
-              <a:t>What survives is coverage. It sees changes the cheap statistic is structurally blind to. Slide 12 has the evidence.</a:t>
+              <a:t>Change the report, or the data underneath it, and verification fails.</a:t>
+            </a:r>
+          </a:p>
+          <a:p>
+            <a:pPr>
+              <a:spcAft>
+                <a:spcPts val="1200"/>
+              </a:spcAft>
+            </a:pPr>
+            <a:r>
+              <a:rPr sz="1700" b="1">
+                <a:solidFill>
+                  <a:srgbClr val="0B6E4F"/>
+                </a:solidFill>
+                <a:latin typeface="Calibri"/>
+              </a:rPr>
+              <a:t>The verifier uses the Python standard library and `cryptography`. It does not import the SDK or the harness.</a:t>
+            </a:r>
+          </a:p>
+          <a:p>
+            <a:pPr>
+              <a:spcAft>
+                <a:spcPts val="1200"/>
+              </a:spcAft>
+            </a:pPr>
+            <a:r>
+              <a:rPr sz="1700" b="0">
+                <a:solidFill>
+                  <a:srgbClr val="1B1B1B"/>
+                </a:solidFill>
+                <a:latin typeface="Calibri"/>
+              </a:rPr>
+              <a:t>A standard whose verification requires the vendor's code is not a standard.</a:t>
+            </a:r>
+          </a:p>
+        </p:txBody>
+      </p:sp>
+      <p:sp>
+        <p:nvSpPr>
+          <p:cNvPr id="5" name="TextBox 4"/>
+          <p:cNvSpPr txBox="1"/>
+          <p:nvPr/>
+        </p:nvSpPr>
+        <p:spPr>
+          <a:xfrm>
+            <a:off x="640080" y="5120640"/>
+            <a:ext cx="10972800" cy="548640"/>
+          </a:xfrm>
+          <a:prstGeom prst="rect">
+            <a:avLst/>
+          </a:prstGeom>
+          <a:noFill/>
+        </p:spPr>
+        <p:txBody>
+          <a:bodyPr wrap="square">
+            <a:spAutoFit/>
+          </a:bodyPr>
+          <a:lstStyle/>
+          <a:p>
+            <a:pPr algn="l">
+              <a:spcAft>
+                <a:spcPts val="600"/>
+              </a:spcAft>
+            </a:pPr>
+            <a:r>
+              <a:rPr sz="1400" b="0">
+                <a:solidFill>
+                  <a:srgbClr val="0B6E4F"/>
+                </a:solidFill>
+                <a:latin typeface="Calibri"/>
+              </a:rPr>
+              <a:t>python verify_report.py harness_effect.json --expect-key &lt;key&gt;   -&gt;   ALL CHECKS PASSED</a:t>
             </a:r>
           </a:p>
         </p:txBody>

</xml_diff>

<commit_message>
Release pass: retire superseded claims, add release checklist, manifest and claim index
Squashed onto main after two rebases left conflict markers in the
changelog history. Content as reviewed in PR #32: retired-claims sweep
of decks and docs, RELEASE.md checklist, release_manifest.py with a
committed manifest for this commit, CLAIM_TO_EVIDENCE.md, and a tracked
copy of the repository audit.
</commit_message>
<xml_diff>
--- a/docs/deck/ari-overview.pptx
+++ b/docs/deck/ari-overview.pptx
@@ -14,6 +14,7 @@
     <p:sldId id="262" r:id="rId13"/>
     <p:sldId id="263" r:id="rId14"/>
     <p:sldId id="264" r:id="rId15"/>
+    <p:sldId id="265" r:id="rId16"/>
   </p:sldIdLst>
   <p:sldSz cx="12191695" cy="6858000" type="screen4x3"/>
   <p:notesSz cx="6858000" cy="9144000"/>
@@ -3208,7 +3209,385 @@
                 </a:solidFill>
                 <a:latin typeface="Calibri"/>
               </a:rPr>
-              <a:t>Every number in this deck is read from a signed measurement. Verification instructions on the last slide.</a:t>
+              <a:t>Numbers are read from the experiment JSON in this repository. Slide 2 lists statements superseded by the 2026-09-16 audit.</a:t>
+            </a:r>
+          </a:p>
+        </p:txBody>
+      </p:sp>
+    </p:spTree>
+  </p:cSld>
+  <p:clrMapOvr>
+    <a:masterClrMapping/>
+  </p:clrMapOvr>
+</p:sld>
+</file>
+
+<file path=ppt/slides/slide10.xml><?xml version="1.0" encoding="utf-8"?>
+<p:sld xmlns:a="http://schemas.openxmlformats.org/drawingml/2006/main" xmlns:p="http://schemas.openxmlformats.org/presentationml/2006/main" xmlns:r="http://schemas.openxmlformats.org/officeDocument/2006/relationships">
+  <p:cSld>
+    <p:spTree>
+      <p:nvGrpSpPr>
+        <p:cNvPr id="1" name=""/>
+        <p:cNvGrpSpPr/>
+        <p:nvPr/>
+      </p:nvGrpSpPr>
+      <p:grpSpPr/>
+      <p:sp>
+        <p:nvSpPr>
+          <p:cNvPr id="2" name="TextBox 1"/>
+          <p:cNvSpPr txBox="1"/>
+          <p:nvPr/>
+        </p:nvSpPr>
+        <p:spPr>
+          <a:xfrm>
+            <a:off x="640080" y="320040"/>
+            <a:ext cx="10972800" cy="320040"/>
+          </a:xfrm>
+          <a:prstGeom prst="rect">
+            <a:avLst/>
+          </a:prstGeom>
+          <a:noFill/>
+        </p:spPr>
+        <p:txBody>
+          <a:bodyPr wrap="square">
+            <a:spAutoFit/>
+          </a:bodyPr>
+          <a:lstStyle/>
+          <a:p>
+            <a:pPr algn="l">
+              <a:spcAft>
+                <a:spcPts val="600"/>
+              </a:spcAft>
+            </a:pPr>
+            <a:r>
+              <a:rPr sz="1200" b="0">
+                <a:solidFill>
+                  <a:srgbClr val="6E6E6E"/>
+                </a:solidFill>
+                <a:latin typeface="Calibri"/>
+              </a:rPr>
+              <a:t>HONEST STATUS</a:t>
+            </a:r>
+          </a:p>
+        </p:txBody>
+      </p:sp>
+      <p:sp>
+        <p:nvSpPr>
+          <p:cNvPr id="3" name="TextBox 2"/>
+          <p:cNvSpPr txBox="1"/>
+          <p:nvPr/>
+        </p:nvSpPr>
+        <p:spPr>
+          <a:xfrm>
+            <a:off x="640080" y="640080"/>
+            <a:ext cx="10972800" cy="822960"/>
+          </a:xfrm>
+          <a:prstGeom prst="rect">
+            <a:avLst/>
+          </a:prstGeom>
+          <a:noFill/>
+        </p:spPr>
+        <p:txBody>
+          <a:bodyPr wrap="square">
+            <a:spAutoFit/>
+          </a:bodyPr>
+          <a:lstStyle/>
+          <a:p>
+            <a:pPr algn="l">
+              <a:spcAft>
+                <a:spcPts val="600"/>
+              </a:spcAft>
+            </a:pPr>
+            <a:r>
+              <a:rPr sz="2800" b="1">
+                <a:solidFill>
+                  <a:srgbClr val="1B1B1B"/>
+                </a:solidFill>
+                <a:latin typeface="Calibri"/>
+              </a:rPr>
+              <a:t>Where we actually are</a:t>
+            </a:r>
+          </a:p>
+        </p:txBody>
+      </p:sp>
+      <p:graphicFrame>
+        <p:nvGraphicFramePr>
+          <p:cNvPr id="4" name="Table 3"/>
+          <p:cNvGraphicFramePr>
+            <a:graphicFrameLocks noGrp="1"/>
+          </p:cNvGraphicFramePr>
+          <p:nvPr/>
+        </p:nvGraphicFramePr>
+        <p:xfrm>
+          <a:off x="822960" y="1828800"/>
+          <a:ext cx="10515600" cy="2743200"/>
+        </p:xfrm>
+        <a:graphic>
+          <a:graphicData uri="http://schemas.openxmlformats.org/drawingml/2006/table">
+            <a:tbl>
+              <a:tblPr firstRow="1" bandRow="1">
+                <a:tableStyleId>{5C22544A-7EE6-4342-B048-85BDC9FD1C3A}</a:tableStyleId>
+              </a:tblPr>
+              <a:tblGrid>
+                <a:gridCol w="3505200"/>
+                <a:gridCol w="3505200"/>
+                <a:gridCol w="3505200"/>
+              </a:tblGrid>
+              <a:tr h="685800">
+                <a:tc>
+                  <a:txBody>
+                    <a:bodyPr/>
+                    <a:lstStyle/>
+                    <a:p>
+                      <a:pPr algn="l"/>
+                      <a:r>
+                        <a:rPr sz="1500" b="1">
+                          <a:latin typeface="Calibri"/>
+                        </a:rPr>
+                        <a:t>Index</a:t>
+                      </a:r>
+                    </a:p>
+                  </a:txBody>
+                  <a:tcPr/>
+                </a:tc>
+                <a:tc>
+                  <a:txBody>
+                    <a:bodyPr/>
+                    <a:lstStyle/>
+                    <a:p>
+                      <a:pPr algn="r"/>
+                      <a:r>
+                        <a:rPr sz="1500" b="1">
+                          <a:latin typeface="Calibri"/>
+                        </a:rPr>
+                        <a:t>Status</a:t>
+                      </a:r>
+                    </a:p>
+                  </a:txBody>
+                  <a:tcPr/>
+                </a:tc>
+                <a:tc>
+                  <a:txBody>
+                    <a:bodyPr/>
+                    <a:lstStyle/>
+                    <a:p>
+                      <a:pPr algn="r"/>
+                      <a:r>
+                        <a:rPr sz="1500" b="1">
+                          <a:latin typeface="Calibri"/>
+                        </a:rPr>
+                        <a:t>Strength of the evidence</a:t>
+                      </a:r>
+                    </a:p>
+                  </a:txBody>
+                  <a:tcPr/>
+                </a:tc>
+              </a:tr>
+              <a:tr h="685800">
+                <a:tc>
+                  <a:txBody>
+                    <a:bodyPr/>
+                    <a:lstStyle/>
+                    <a:p>
+                      <a:pPr algn="l"/>
+                      <a:r>
+                        <a:rPr sz="1500" b="0">
+                          <a:latin typeface="Calibri"/>
+                        </a:rPr>
+                        <a:t>ARI-R</a:t>
+                      </a:r>
+                    </a:p>
+                  </a:txBody>
+                  <a:tcPr/>
+                </a:tc>
+                <a:tc>
+                  <a:txBody>
+                    <a:bodyPr/>
+                    <a:lstStyle/>
+                    <a:p>
+                      <a:pPr algn="r"/>
+                      <a:r>
+                        <a:rPr sz="1500" b="0">
+                          <a:latin typeface="Calibri"/>
+                        </a:rPr>
+                        <a:t>Measured on CPU and GPU</a:t>
+                      </a:r>
+                    </a:p>
+                  </a:txBody>
+                  <a:tcPr/>
+                </a:tc>
+                <a:tc>
+                  <a:txBody>
+                    <a:bodyPr/>
+                    <a:lstStyle/>
+                    <a:p>
+                      <a:pPr algn="r"/>
+                      <a:r>
+                        <a:rPr sz="1500" b="0">
+                          <a:latin typeface="Calibri"/>
+                        </a:rPr>
+                        <a:t>TF32 association replicated; attribution needs profiling</a:t>
+                      </a:r>
+                    </a:p>
+                  </a:txBody>
+                  <a:tcPr/>
+                </a:tc>
+              </a:tr>
+              <a:tr h="685800">
+                <a:tc>
+                  <a:txBody>
+                    <a:bodyPr/>
+                    <a:lstStyle/>
+                    <a:p>
+                      <a:pPr algn="l"/>
+                      <a:r>
+                        <a:rPr sz="1500" b="0">
+                          <a:latin typeface="Calibri"/>
+                        </a:rPr>
+                        <a:t>ARI-D</a:t>
+                      </a:r>
+                    </a:p>
+                  </a:txBody>
+                  <a:tcPr/>
+                </a:tc>
+                <a:tc>
+                  <a:txBody>
+                    <a:bodyPr/>
+                    <a:lstStyle/>
+                    <a:p>
+                      <a:pPr algn="r"/>
+                      <a:r>
+                        <a:rPr sz="1500" b="0">
+                          <a:latin typeface="Calibri"/>
+                        </a:rPr>
+                        <a:t>Measured on two models</a:t>
+                      </a:r>
+                    </a:p>
+                  </a:txBody>
+                  <a:tcPr/>
+                </a:tc>
+                <a:tc>
+                  <a:txBody>
+                    <a:bodyPr/>
+                    <a:lstStyle/>
+                    <a:p>
+                      <a:pPr algn="r"/>
+                      <a:r>
+                        <a:rPr sz="1500" b="0">
+                          <a:latin typeface="Calibri"/>
+                        </a:rPr>
+                        <a:t>Real, but a cheaper statistic competes</a:t>
+                      </a:r>
+                    </a:p>
+                  </a:txBody>
+                  <a:tcPr/>
+                </a:tc>
+              </a:tr>
+              <a:tr h="685800">
+                <a:tc>
+                  <a:txBody>
+                    <a:bodyPr/>
+                    <a:lstStyle/>
+                    <a:p>
+                      <a:pPr algn="l"/>
+                      <a:r>
+                        <a:rPr sz="1500" b="0">
+                          <a:latin typeface="Calibri"/>
+                        </a:rPr>
+                        <a:t>ARI-E</a:t>
+                      </a:r>
+                    </a:p>
+                  </a:txBody>
+                  <a:tcPr/>
+                </a:tc>
+                <a:tc>
+                  <a:txBody>
+                    <a:bodyPr/>
+                    <a:lstStyle/>
+                    <a:p>
+                      <a:pPr algn="r"/>
+                      <a:r>
+                        <a:rPr sz="1500" b="0">
+                          <a:latin typeface="Calibri"/>
+                        </a:rPr>
+                        <a:t>Historical analysis, withheld</a:t>
+                      </a:r>
+                    </a:p>
+                  </a:txBody>
+                  <a:tcPr/>
+                </a:tc>
+                <a:tc>
+                  <a:txBody>
+                    <a:bodyPr/>
+                    <a:lstStyle/>
+                    <a:p>
+                      <a:pPr algn="r"/>
+                      <a:r>
+                        <a:rPr sz="1500" b="0">
+                          <a:latin typeface="Calibri"/>
+                        </a:rPr>
+                        <a:t>Pending rerun with the corrected estimator</a:t>
+                      </a:r>
+                    </a:p>
+                  </a:txBody>
+                  <a:tcPr/>
+                </a:tc>
+              </a:tr>
+            </a:tbl>
+          </a:graphicData>
+        </a:graphic>
+      </p:graphicFrame>
+      <p:sp>
+        <p:nvSpPr>
+          <p:cNvPr id="5" name="TextBox 4"/>
+          <p:cNvSpPr txBox="1"/>
+          <p:nvPr/>
+        </p:nvSpPr>
+        <p:spPr>
+          <a:xfrm>
+            <a:off x="822960" y="4480560"/>
+            <a:ext cx="10607040" cy="4206240"/>
+          </a:xfrm>
+          <a:prstGeom prst="rect">
+            <a:avLst/>
+          </a:prstGeom>
+          <a:noFill/>
+        </p:spPr>
+        <p:txBody>
+          <a:bodyPr wrap="square">
+            <a:spAutoFit/>
+          </a:bodyPr>
+          <a:lstStyle/>
+          <a:p>
+            <a:pPr>
+              <a:spcAft>
+                <a:spcPts val="1200"/>
+              </a:spcAft>
+            </a:pPr>
+            <a:r>
+              <a:rPr sz="1500" b="1">
+                <a:solidFill>
+                  <a:srgbClr val="C1543A"/>
+                </a:solidFill>
+                <a:latin typeface="Calibri"/>
+              </a:rPr>
+              <a:t>Known weakness, stated up front: at the decoding layer a simple top-2 margin statistic gets 86% of the signal for a fraction of the storage.</a:t>
+            </a:r>
+          </a:p>
+          <a:p>
+            <a:pPr>
+              <a:spcAft>
+                <a:spcPts val="1200"/>
+              </a:spcAft>
+            </a:pPr>
+            <a:r>
+              <a:rPr sz="1500" b="0">
+                <a:solidFill>
+                  <a:srgbClr val="1B1B1B"/>
+                </a:solidFill>
+                <a:latin typeface="Calibri"/>
+              </a:rPr>
+              <a:t>What survives is coverage. It sees changes the cheap statistic is structurally blind to. The technical deck's tail-coverage slide has the evidence.</a:t>
             </a:r>
           </a:p>
         </p:txBody>
@@ -3265,7 +3644,7 @@
                 </a:solidFill>
                 <a:latin typeface="Calibri"/>
               </a:rPr>
-              <a:t>THE GAP</a:t>
+              <a:t>READ FIRST: 2026-09-16 REPOSITORY AUDIT</a:t>
             </a:r>
           </a:p>
         </p:txBody>
@@ -3304,7 +3683,7 @@
                 </a:solidFill>
                 <a:latin typeface="Calibri"/>
               </a:rPr>
-              <a:t>The problem: your dashboard cannot see the change</a:t>
+              <a:t>Superseded statements</a:t>
             </a:r>
           </a:p>
         </p:txBody>
@@ -3337,6 +3716,253 @@
               </a:spcAft>
             </a:pPr>
             <a:r>
+              <a:rPr sz="1400" b="1">
+                <a:solidFill>
+                  <a:srgbClr val="1B1B1B"/>
+                </a:solidFill>
+                <a:latin typeface="Calibri"/>
+              </a:rPr>
+              <a:t>This deck is a historical presentation artifact, regenerated from the experiment JSON on 2026-09-16. It is not maintained scientific evidence. Use the paper and docs/REPOSITORY_AUDIT.md for current claims.</a:t>
+            </a:r>
+          </a:p>
+          <a:p>
+            <a:pPr>
+              <a:spcAft>
+                <a:spcPts val="1200"/>
+              </a:spcAft>
+            </a:pPr>
+            <a:r>
+              <a:rPr sz="1400" b="0">
+                <a:solidFill>
+                  <a:srgbClr val="C1543A"/>
+                </a:solidFill>
+                <a:latin typeface="Calibri"/>
+              </a:rPr>
+              <a:t>ARI-E slides: the harness-effect numbers come from an earlier estimator and a partial trajectory export. The paper withholds them pending a rerun.</a:t>
+            </a:r>
+          </a:p>
+          <a:p>
+            <a:pPr>
+              <a:spcAft>
+                <a:spcPts val="1200"/>
+              </a:spcAft>
+            </a:pPr>
+            <a:r>
+              <a:rPr sz="1400" b="0">
+                <a:solidFill>
+                  <a:srgbClr val="C1543A"/>
+                </a:solidFill>
+                <a:latin typeface="Calibri"/>
+              </a:rPr>
+              <a:t>Self-hosted `time` cells were immediate repeats, not captures after a gap greater than 24 hours. The self-hosted comparable core is incomplete.</a:t>
+            </a:r>
+          </a:p>
+          <a:p>
+            <a:pPr>
+              <a:spcAft>
+                <a:spcPts val="1200"/>
+              </a:spcAft>
+            </a:pPr>
+            <a:r>
+              <a:rPr sz="1400" b="0">
+                <a:solidFill>
+                  <a:srgbClr val="1B1B1B"/>
+                </a:solidFill>
+                <a:latin typeface="Calibri"/>
+              </a:rPr>
+              <a:t>A nonsignificant Recall@10 difference is not equivalence. Ranked result lists did change under the same conditions.</a:t>
+            </a:r>
+          </a:p>
+          <a:p>
+            <a:pPr>
+              <a:spcAft>
+                <a:spcPts val="1200"/>
+              </a:spcAft>
+            </a:pPr>
+            <a:r>
+              <a:rPr sz="1400" b="0">
+                <a:solidFill>
+                  <a:srgbClr val="1B1B1B"/>
+                </a:solidFill>
+                <a:latin typeface="Calibri"/>
+              </a:rPr>
+              <a:t>'Early warning' means a changed code at a step whose token did not change. It is not a validated predictor of later failure.</a:t>
+            </a:r>
+          </a:p>
+          <a:p>
+            <a:pPr>
+              <a:spcAft>
+                <a:spcPts val="1200"/>
+              </a:spcAft>
+            </a:pPr>
+            <a:r>
+              <a:rPr sz="1400" b="0">
+                <a:solidFill>
+                  <a:srgbClr val="1B1B1B"/>
+                </a:solidFill>
+                <a:latin typeface="Calibri"/>
+              </a:rPr>
+              <a:t>TF32 and kernel-selection mechanism statements are consistent with the data but were not established by profiling.</a:t>
+            </a:r>
+          </a:p>
+          <a:p>
+            <a:pPr>
+              <a:spcAft>
+                <a:spcPts val="1200"/>
+              </a:spcAft>
+            </a:pPr>
+            <a:r>
+              <a:rPr sz="1400" b="0">
+                <a:solidFill>
+                  <a:srgbClr val="1B1B1B"/>
+                </a:solidFill>
+                <a:latin typeface="Calibri"/>
+              </a:rPr>
+              <a:t>Decoding disagreement rates labelled H-bar are packed-byte rates, not bit or coordinate rates.</a:t>
+            </a:r>
+          </a:p>
+          <a:p>
+            <a:pPr>
+              <a:spcAft>
+                <a:spcPts val="1200"/>
+              </a:spcAft>
+            </a:pPr>
+            <a:r>
+              <a:rPr sz="1400" b="0">
+                <a:solidFill>
+                  <a:srgbClr val="6E6E6E"/>
+                </a:solidFill>
+                <a:latin typeface="Calibri"/>
+              </a:rPr>
+              <a:t>Index of superseded statements: docs/RETIRED_CLAIMS.md.</a:t>
+            </a:r>
+          </a:p>
+        </p:txBody>
+      </p:sp>
+    </p:spTree>
+  </p:cSld>
+  <p:clrMapOvr>
+    <a:masterClrMapping/>
+  </p:clrMapOvr>
+</p:sld>
+</file>
+
+<file path=ppt/slides/slide3.xml><?xml version="1.0" encoding="utf-8"?>
+<p:sld xmlns:a="http://schemas.openxmlformats.org/drawingml/2006/main" xmlns:p="http://schemas.openxmlformats.org/presentationml/2006/main" xmlns:r="http://schemas.openxmlformats.org/officeDocument/2006/relationships">
+  <p:cSld>
+    <p:spTree>
+      <p:nvGrpSpPr>
+        <p:cNvPr id="1" name=""/>
+        <p:cNvGrpSpPr/>
+        <p:nvPr/>
+      </p:nvGrpSpPr>
+      <p:grpSpPr/>
+      <p:sp>
+        <p:nvSpPr>
+          <p:cNvPr id="2" name="TextBox 1"/>
+          <p:cNvSpPr txBox="1"/>
+          <p:nvPr/>
+        </p:nvSpPr>
+        <p:spPr>
+          <a:xfrm>
+            <a:off x="640080" y="320040"/>
+            <a:ext cx="10972800" cy="320040"/>
+          </a:xfrm>
+          <a:prstGeom prst="rect">
+            <a:avLst/>
+          </a:prstGeom>
+          <a:noFill/>
+        </p:spPr>
+        <p:txBody>
+          <a:bodyPr wrap="square">
+            <a:spAutoFit/>
+          </a:bodyPr>
+          <a:lstStyle/>
+          <a:p>
+            <a:pPr algn="l">
+              <a:spcAft>
+                <a:spcPts val="600"/>
+              </a:spcAft>
+            </a:pPr>
+            <a:r>
+              <a:rPr sz="1200" b="0">
+                <a:solidFill>
+                  <a:srgbClr val="6E6E6E"/>
+                </a:solidFill>
+                <a:latin typeface="Calibri"/>
+              </a:rPr>
+              <a:t>THE GAP</a:t>
+            </a:r>
+          </a:p>
+        </p:txBody>
+      </p:sp>
+      <p:sp>
+        <p:nvSpPr>
+          <p:cNvPr id="3" name="TextBox 2"/>
+          <p:cNvSpPr txBox="1"/>
+          <p:nvPr/>
+        </p:nvSpPr>
+        <p:spPr>
+          <a:xfrm>
+            <a:off x="640080" y="640080"/>
+            <a:ext cx="10972800" cy="822960"/>
+          </a:xfrm>
+          <a:prstGeom prst="rect">
+            <a:avLst/>
+          </a:prstGeom>
+          <a:noFill/>
+        </p:spPr>
+        <p:txBody>
+          <a:bodyPr wrap="square">
+            <a:spAutoFit/>
+          </a:bodyPr>
+          <a:lstStyle/>
+          <a:p>
+            <a:pPr algn="l">
+              <a:spcAft>
+                <a:spcPts val="600"/>
+              </a:spcAft>
+            </a:pPr>
+            <a:r>
+              <a:rPr sz="2800" b="1">
+                <a:solidFill>
+                  <a:srgbClr val="1B1B1B"/>
+                </a:solidFill>
+                <a:latin typeface="Calibri"/>
+              </a:rPr>
+              <a:t>The problem: your dashboard cannot see the change</a:t>
+            </a:r>
+          </a:p>
+        </p:txBody>
+      </p:sp>
+      <p:sp>
+        <p:nvSpPr>
+          <p:cNvPr id="4" name="TextBox 3"/>
+          <p:cNvSpPr txBox="1"/>
+          <p:nvPr/>
+        </p:nvSpPr>
+        <p:spPr>
+          <a:xfrm>
+            <a:off x="822960" y="1737360"/>
+            <a:ext cx="10607040" cy="4206240"/>
+          </a:xfrm>
+          <a:prstGeom prst="rect">
+            <a:avLst/>
+          </a:prstGeom>
+          <a:noFill/>
+        </p:spPr>
+        <p:txBody>
+          <a:bodyPr wrap="square">
+            <a:spAutoFit/>
+          </a:bodyPr>
+          <a:lstStyle/>
+          <a:p>
+            <a:pPr>
+              <a:spcAft>
+                <a:spcPts val="1200"/>
+              </a:spcAft>
+            </a:pPr>
+            <a:r>
               <a:rPr sz="1700" b="1">
                 <a:solidFill>
                   <a:srgbClr val="1B1B1B"/>
@@ -3459,7 +4085,7 @@
 </p:sld>
 </file>
 
-<file path=ppt/slides/slide3.xml><?xml version="1.0" encoding="utf-8"?>
+<file path=ppt/slides/slide4.xml><?xml version="1.0" encoding="utf-8"?>
 <p:sld xmlns:a="http://schemas.openxmlformats.org/drawingml/2006/main" xmlns:p="http://schemas.openxmlformats.org/presentationml/2006/main" xmlns:r="http://schemas.openxmlformats.org/officeDocument/2006/relationships">
   <p:cSld>
     <p:spTree>
@@ -3837,7 +4463,7 @@
 </p:sld>
 </file>
 
-<file path=ppt/slides/slide4.xml><?xml version="1.0" encoding="utf-8"?>
+<file path=ppt/slides/slide5.xml><?xml version="1.0" encoding="utf-8"?>
 <p:sld xmlns:a="http://schemas.openxmlformats.org/drawingml/2006/main" xmlns:p="http://schemas.openxmlformats.org/presentationml/2006/main" xmlns:r="http://schemas.openxmlformats.org/officeDocument/2006/relationships">
   <p:cSld>
     <p:spTree>
@@ -4200,7 +4826,7 @@
                 </a:solidFill>
                 <a:latin typeface="Calibri"/>
               </a:rPr>
-              <a:t>The audited system and the served system disagree on 47% of documents. Retrieval quality moves by exactly zero. Turning TF32 off restores agreement, which is what attributes the effect to that one switch.</a:t>
+              <a:t>The audited system and the served system disagree on 47% of documents. No Recall@10 change was detected; a nonsignificant difference is not equivalence. Turning TF32 off restores agreement, which associates the effect with that one switch.</a:t>
             </a:r>
           </a:p>
         </p:txBody>
@@ -4213,7 +4839,7 @@
 </p:sld>
 </file>
 
-<file path=ppt/slides/slide5.xml><?xml version="1.0" encoding="utf-8"?>
+<file path=ppt/slides/slide6.xml><?xml version="1.0" encoding="utf-8"?>
 <p:sld xmlns:a="http://schemas.openxmlformats.org/drawingml/2006/main" xmlns:p="http://schemas.openxmlformats.org/presentationml/2006/main" xmlns:r="http://schemas.openxmlformats.org/officeDocument/2006/relationships">
   <p:cSld>
     <p:spTree>
@@ -4542,7 +5168,7 @@
                 </a:solidFill>
                 <a:latin typeface="Calibri"/>
               </a:rPr>
-              <a:t>Output comparison is silent across the entire run. The instrument reads the change at every step. That is the difference between finding out now and finding out from a customer.</a:t>
+              <a:t>Output comparison is silent across the entire run. The instrument reads a code change at every step while the token is unchanged. This is contemporaneous disagreement, not a validated predictor of later failure.</a:t>
             </a:r>
           </a:p>
         </p:txBody>
@@ -4555,7 +5181,7 @@
 </p:sld>
 </file>
 
-<file path=ppt/slides/slide6.xml><?xml version="1.0" encoding="utf-8"?>
+<file path=ppt/slides/slide7.xml><?xml version="1.0" encoding="utf-8"?>
 <p:sld xmlns:a="http://schemas.openxmlformats.org/drawingml/2006/main" xmlns:p="http://schemas.openxmlformats.org/presentationml/2006/main" xmlns:r="http://schemas.openxmlformats.org/officeDocument/2006/relationships">
   <p:cSld>
     <p:spTree>
@@ -4599,7 +5225,7 @@
                 </a:solidFill>
                 <a:latin typeface="Calibri"/>
               </a:rPr>
-              <a:t>USE CASE 3</a:t>
+              <a:t>USE CASE 3. HISTORICAL: WITHHELD FROM THE PAPER PENDING RERUN</a:t>
             </a:r>
           </a:p>
         </p:txBody>
@@ -4862,11 +5488,11 @@
             <a:r>
               <a:rPr sz="1500" b="0">
                 <a:solidFill>
-                  <a:srgbClr val="1B1B1B"/>
+                  <a:srgbClr val="C1543A"/>
                 </a:solidFill>
                 <a:latin typeface="Calibri"/>
               </a:rPr>
-              <a:t>The wrapper mattered more than the model. Benchmark tables that name only the model are not comparable.</a:t>
+              <a:t>Historical reading: the wrapper effect exceeded the model effect for these pairs. Superseded: earlier estimator, partial export; not a current result.</a:t>
             </a:r>
           </a:p>
         </p:txBody>
@@ -4879,7 +5505,7 @@
 </p:sld>
 </file>
 
-<file path=ppt/slides/slide7.xml><?xml version="1.0" encoding="utf-8"?>
+<file path=ppt/slides/slide8.xml><?xml version="1.0" encoding="utf-8"?>
 <p:sld xmlns:a="http://schemas.openxmlformats.org/drawingml/2006/main" xmlns:p="http://schemas.openxmlformats.org/presentationml/2006/main" xmlns:r="http://schemas.openxmlformats.org/officeDocument/2006/relationships">
   <p:cSld>
     <p:spTree>
@@ -4923,7 +5549,7 @@
                 </a:solidFill>
                 <a:latin typeface="Calibri"/>
               </a:rPr>
-              <a:t>WHY THIS IS HARD TO COPY</a:t>
+              <a:t>WHY THIS IS HARD TO COPY. HISTORICAL NUMBERS, SEE SLIDE 2</a:t>
             </a:r>
           </a:p>
         </p:txBody>
@@ -5196,229 +5822,7 @@
                 </a:solidFill>
                 <a:latin typeface="Calibri"/>
               </a:rPr>
-              <a:t>The naive number is 2.4x too large. Across every comparison we ran, the control removed 59-74% of the apparent effect. A competitor without it reports noise as signal.</a:t>
-            </a:r>
-          </a:p>
-        </p:txBody>
-      </p:sp>
-    </p:spTree>
-  </p:cSld>
-  <p:clrMapOvr>
-    <a:masterClrMapping/>
-  </p:clrMapOvr>
-</p:sld>
-</file>
-
-<file path=ppt/slides/slide8.xml><?xml version="1.0" encoding="utf-8"?>
-<p:sld xmlns:a="http://schemas.openxmlformats.org/drawingml/2006/main" xmlns:p="http://schemas.openxmlformats.org/presentationml/2006/main" xmlns:r="http://schemas.openxmlformats.org/officeDocument/2006/relationships">
-  <p:cSld>
-    <p:spTree>
-      <p:nvGrpSpPr>
-        <p:cNvPr id="1" name=""/>
-        <p:cNvGrpSpPr/>
-        <p:nvPr/>
-      </p:nvGrpSpPr>
-      <p:grpSpPr/>
-      <p:sp>
-        <p:nvSpPr>
-          <p:cNvPr id="2" name="TextBox 1"/>
-          <p:cNvSpPr txBox="1"/>
-          <p:nvPr/>
-        </p:nvSpPr>
-        <p:spPr>
-          <a:xfrm>
-            <a:off x="640080" y="320040"/>
-            <a:ext cx="10972800" cy="320040"/>
-          </a:xfrm>
-          <a:prstGeom prst="rect">
-            <a:avLst/>
-          </a:prstGeom>
-          <a:noFill/>
-        </p:spPr>
-        <p:txBody>
-          <a:bodyPr wrap="square">
-            <a:spAutoFit/>
-          </a:bodyPr>
-          <a:lstStyle/>
-          <a:p>
-            <a:pPr algn="l">
-              <a:spcAft>
-                <a:spcPts val="600"/>
-              </a:spcAft>
-            </a:pPr>
-            <a:r>
-              <a:rPr sz="1200" b="0">
-                <a:solidFill>
-                  <a:srgbClr val="6E6E6E"/>
-                </a:solidFill>
-                <a:latin typeface="Calibri"/>
-              </a:rPr>
-              <a:t>WHY IT IS CREDIBLE</a:t>
-            </a:r>
-          </a:p>
-        </p:txBody>
-      </p:sp>
-      <p:sp>
-        <p:nvSpPr>
-          <p:cNvPr id="3" name="TextBox 2"/>
-          <p:cNvSpPr txBox="1"/>
-          <p:nvPr/>
-        </p:nvSpPr>
-        <p:spPr>
-          <a:xfrm>
-            <a:off x="640080" y="640080"/>
-            <a:ext cx="10972800" cy="822960"/>
-          </a:xfrm>
-          <a:prstGeom prst="rect">
-            <a:avLst/>
-          </a:prstGeom>
-          <a:noFill/>
-        </p:spPr>
-        <p:txBody>
-          <a:bodyPr wrap="square">
-            <a:spAutoFit/>
-          </a:bodyPr>
-          <a:lstStyle/>
-          <a:p>
-            <a:pPr algn="l">
-              <a:spcAft>
-                <a:spcPts val="600"/>
-              </a:spcAft>
-            </a:pPr>
-            <a:r>
-              <a:rPr sz="2800" b="1">
-                <a:solidFill>
-                  <a:srgbClr val="1B1B1B"/>
-                </a:solidFill>
-                <a:latin typeface="Calibri"/>
-              </a:rPr>
-              <a:t>Anyone can check our numbers without trusting us</a:t>
-            </a:r>
-          </a:p>
-        </p:txBody>
-      </p:sp>
-      <p:sp>
-        <p:nvSpPr>
-          <p:cNvPr id="4" name="TextBox 3"/>
-          <p:cNvSpPr txBox="1"/>
-          <p:nvPr/>
-        </p:nvSpPr>
-        <p:spPr>
-          <a:xfrm>
-            <a:off x="822960" y="1737360"/>
-            <a:ext cx="10607040" cy="4206240"/>
-          </a:xfrm>
-          <a:prstGeom prst="rect">
-            <a:avLst/>
-          </a:prstGeom>
-          <a:noFill/>
-        </p:spPr>
-        <p:txBody>
-          <a:bodyPr wrap="square">
-            <a:spAutoFit/>
-          </a:bodyPr>
-          <a:lstStyle/>
-          <a:p>
-            <a:pPr>
-              <a:spcAft>
-                <a:spcPts val="1200"/>
-              </a:spcAft>
-            </a:pPr>
-            <a:r>
-              <a:rPr sz="1700" b="1">
-                <a:solidFill>
-                  <a:srgbClr val="1B1B1B"/>
-                </a:solidFill>
-                <a:latin typeface="Calibri"/>
-              </a:rPr>
-              <a:t>Every report is cryptographically signed and bound to the exact data it came from.</a:t>
-            </a:r>
-          </a:p>
-          <a:p>
-            <a:pPr>
-              <a:spcAft>
-                <a:spcPts val="1200"/>
-              </a:spcAft>
-            </a:pPr>
-            <a:r>
-              <a:rPr sz="1700" b="0">
-                <a:solidFill>
-                  <a:srgbClr val="1B1B1B"/>
-                </a:solidFill>
-                <a:latin typeface="Calibri"/>
-              </a:rPr>
-              <a:t>Change the report, or the data underneath it, and verification fails.</a:t>
-            </a:r>
-          </a:p>
-          <a:p>
-            <a:pPr>
-              <a:spcAft>
-                <a:spcPts val="1200"/>
-              </a:spcAft>
-            </a:pPr>
-            <a:r>
-              <a:rPr sz="1700" b="1">
-                <a:solidFill>
-                  <a:srgbClr val="0B6E4F"/>
-                </a:solidFill>
-                <a:latin typeface="Calibri"/>
-              </a:rPr>
-              <a:t>The verifier is 175 lines and does not use our software.</a:t>
-            </a:r>
-          </a:p>
-          <a:p>
-            <a:pPr>
-              <a:spcAft>
-                <a:spcPts val="1200"/>
-              </a:spcAft>
-            </a:pPr>
-            <a:r>
-              <a:rPr sz="1700" b="0">
-                <a:solidFill>
-                  <a:srgbClr val="1B1B1B"/>
-                </a:solidFill>
-                <a:latin typeface="Calibri"/>
-              </a:rPr>
-              <a:t>A standard whose verification requires the vendor's code is not a standard.</a:t>
-            </a:r>
-          </a:p>
-        </p:txBody>
-      </p:sp>
-      <p:sp>
-        <p:nvSpPr>
-          <p:cNvPr id="5" name="TextBox 4"/>
-          <p:cNvSpPr txBox="1"/>
-          <p:nvPr/>
-        </p:nvSpPr>
-        <p:spPr>
-          <a:xfrm>
-            <a:off x="640080" y="5120640"/>
-            <a:ext cx="10972800" cy="548640"/>
-          </a:xfrm>
-          <a:prstGeom prst="rect">
-            <a:avLst/>
-          </a:prstGeom>
-          <a:noFill/>
-        </p:spPr>
-        <p:txBody>
-          <a:bodyPr wrap="square">
-            <a:spAutoFit/>
-          </a:bodyPr>
-          <a:lstStyle/>
-          <a:p>
-            <a:pPr algn="l">
-              <a:spcAft>
-                <a:spcPts val="600"/>
-              </a:spcAft>
-            </a:pPr>
-            <a:r>
-              <a:rPr sz="1400" b="0">
-                <a:solidFill>
-                  <a:srgbClr val="0B6E4F"/>
-                </a:solidFill>
-                <a:latin typeface="Calibri"/>
-              </a:rPr>
-              <a:t>python verify_report.py harness_effect.json --expect-key &lt;key&gt;   -&gt;   ALL CHECKS PASSED</a:t>
+              <a:t>In the historical run the control removed 59-74% of the apparent effect. The estimator has since been corrected and the numbers await a rerun; the method point stands, the values do not.</a:t>
             </a:r>
           </a:p>
         </p:txBody>
@@ -5475,7 +5879,7 @@
                 </a:solidFill>
                 <a:latin typeface="Calibri"/>
               </a:rPr>
-              <a:t>HONEST STATUS</a:t>
+              <a:t>WHY IT IS CREDIBLE</a:t>
             </a:r>
           </a:p>
         </p:txBody>
@@ -5514,247 +5918,20 @@
                 </a:solidFill>
                 <a:latin typeface="Calibri"/>
               </a:rPr>
-              <a:t>Where we actually are</a:t>
-            </a:r>
-          </a:p>
-        </p:txBody>
-      </p:sp>
-      <p:graphicFrame>
-        <p:nvGraphicFramePr>
-          <p:cNvPr id="4" name="Table 3"/>
-          <p:cNvGraphicFramePr>
-            <a:graphicFrameLocks noGrp="1"/>
-          </p:cNvGraphicFramePr>
-          <p:nvPr/>
-        </p:nvGraphicFramePr>
-        <p:xfrm>
-          <a:off x="822960" y="1828800"/>
-          <a:ext cx="10515600" cy="2743200"/>
-        </p:xfrm>
-        <a:graphic>
-          <a:graphicData uri="http://schemas.openxmlformats.org/drawingml/2006/table">
-            <a:tbl>
-              <a:tblPr firstRow="1" bandRow="1">
-                <a:tableStyleId>{5C22544A-7EE6-4342-B048-85BDC9FD1C3A}</a:tableStyleId>
-              </a:tblPr>
-              <a:tblGrid>
-                <a:gridCol w="3505200"/>
-                <a:gridCol w="3505200"/>
-                <a:gridCol w="3505200"/>
-              </a:tblGrid>
-              <a:tr h="685800">
-                <a:tc>
-                  <a:txBody>
-                    <a:bodyPr/>
-                    <a:lstStyle/>
-                    <a:p>
-                      <a:pPr algn="l"/>
-                      <a:r>
-                        <a:rPr sz="1500" b="1">
-                          <a:latin typeface="Calibri"/>
-                        </a:rPr>
-                        <a:t>Index</a:t>
-                      </a:r>
-                    </a:p>
-                  </a:txBody>
-                  <a:tcPr/>
-                </a:tc>
-                <a:tc>
-                  <a:txBody>
-                    <a:bodyPr/>
-                    <a:lstStyle/>
-                    <a:p>
-                      <a:pPr algn="r"/>
-                      <a:r>
-                        <a:rPr sz="1500" b="1">
-                          <a:latin typeface="Calibri"/>
-                        </a:rPr>
-                        <a:t>Status</a:t>
-                      </a:r>
-                    </a:p>
-                  </a:txBody>
-                  <a:tcPr/>
-                </a:tc>
-                <a:tc>
-                  <a:txBody>
-                    <a:bodyPr/>
-                    <a:lstStyle/>
-                    <a:p>
-                      <a:pPr algn="r"/>
-                      <a:r>
-                        <a:rPr sz="1500" b="1">
-                          <a:latin typeface="Calibri"/>
-                        </a:rPr>
-                        <a:t>Strength of the evidence</a:t>
-                      </a:r>
-                    </a:p>
-                  </a:txBody>
-                  <a:tcPr/>
-                </a:tc>
-              </a:tr>
-              <a:tr h="685800">
-                <a:tc>
-                  <a:txBody>
-                    <a:bodyPr/>
-                    <a:lstStyle/>
-                    <a:p>
-                      <a:pPr algn="l"/>
-                      <a:r>
-                        <a:rPr sz="1500" b="0">
-                          <a:latin typeface="Calibri"/>
-                        </a:rPr>
-                        <a:t>ARI-R</a:t>
-                      </a:r>
-                    </a:p>
-                  </a:txBody>
-                  <a:tcPr/>
-                </a:tc>
-                <a:tc>
-                  <a:txBody>
-                    <a:bodyPr/>
-                    <a:lstStyle/>
-                    <a:p>
-                      <a:pPr algn="r"/>
-                      <a:r>
-                        <a:rPr sz="1500" b="0">
-                          <a:latin typeface="Calibri"/>
-                        </a:rPr>
-                        <a:t>Measured on CPU and GPU</a:t>
-                      </a:r>
-                    </a:p>
-                  </a:txBody>
-                  <a:tcPr/>
-                </a:tc>
-                <a:tc>
-                  <a:txBody>
-                    <a:bodyPr/>
-                    <a:lstStyle/>
-                    <a:p>
-                      <a:pPr algn="r"/>
-                      <a:r>
-                        <a:rPr sz="1500" b="0">
-                          <a:latin typeface="Calibri"/>
-                        </a:rPr>
-                        <a:t>Strong. The TF32 result is clean</a:t>
-                      </a:r>
-                    </a:p>
-                  </a:txBody>
-                  <a:tcPr/>
-                </a:tc>
-              </a:tr>
-              <a:tr h="685800">
-                <a:tc>
-                  <a:txBody>
-                    <a:bodyPr/>
-                    <a:lstStyle/>
-                    <a:p>
-                      <a:pPr algn="l"/>
-                      <a:r>
-                        <a:rPr sz="1500" b="0">
-                          <a:latin typeface="Calibri"/>
-                        </a:rPr>
-                        <a:t>ARI-D</a:t>
-                      </a:r>
-                    </a:p>
-                  </a:txBody>
-                  <a:tcPr/>
-                </a:tc>
-                <a:tc>
-                  <a:txBody>
-                    <a:bodyPr/>
-                    <a:lstStyle/>
-                    <a:p>
-                      <a:pPr algn="r"/>
-                      <a:r>
-                        <a:rPr sz="1500" b="0">
-                          <a:latin typeface="Calibri"/>
-                        </a:rPr>
-                        <a:t>Measured on two models</a:t>
-                      </a:r>
-                    </a:p>
-                  </a:txBody>
-                  <a:tcPr/>
-                </a:tc>
-                <a:tc>
-                  <a:txBody>
-                    <a:bodyPr/>
-                    <a:lstStyle/>
-                    <a:p>
-                      <a:pPr algn="r"/>
-                      <a:r>
-                        <a:rPr sz="1500" b="0">
-                          <a:latin typeface="Calibri"/>
-                        </a:rPr>
-                        <a:t>Real, but a cheaper statistic competes</a:t>
-                      </a:r>
-                    </a:p>
-                  </a:txBody>
-                  <a:tcPr/>
-                </a:tc>
-              </a:tr>
-              <a:tr h="685800">
-                <a:tc>
-                  <a:txBody>
-                    <a:bodyPr/>
-                    <a:lstStyle/>
-                    <a:p>
-                      <a:pPr algn="l"/>
-                      <a:r>
-                        <a:rPr sz="1500" b="0">
-                          <a:latin typeface="Calibri"/>
-                        </a:rPr>
-                        <a:t>ARI-E</a:t>
-                      </a:r>
-                    </a:p>
-                  </a:txBody>
-                  <a:tcPr/>
-                </a:tc>
-                <a:tc>
-                  <a:txBody>
-                    <a:bodyPr/>
-                    <a:lstStyle/>
-                    <a:p>
-                      <a:pPr algn="r"/>
-                      <a:r>
-                        <a:rPr sz="1500" b="0">
-                          <a:latin typeface="Calibri"/>
-                        </a:rPr>
-                        <a:t>22,000 real agent runs</a:t>
-                      </a:r>
-                    </a:p>
-                  </a:txBody>
-                  <a:tcPr/>
-                </a:tc>
-                <a:tc>
-                  <a:txBody>
-                    <a:bodyPr/>
-                    <a:lstStyle/>
-                    <a:p>
-                      <a:pPr algn="r"/>
-                      <a:r>
-                        <a:rPr sz="1500" b="0">
-                          <a:latin typeface="Calibri"/>
-                        </a:rPr>
-                        <a:t>Strong. Largest effect of the three</a:t>
-                      </a:r>
-                    </a:p>
-                  </a:txBody>
-                  <a:tcPr/>
-                </a:tc>
-              </a:tr>
-            </a:tbl>
-          </a:graphicData>
-        </a:graphic>
-      </p:graphicFrame>
-      <p:sp>
-        <p:nvSpPr>
-          <p:cNvPr id="5" name="TextBox 4"/>
+              <a:t>Anyone can check our numbers without trusting us</a:t>
+            </a:r>
+          </a:p>
+        </p:txBody>
+      </p:sp>
+      <p:sp>
+        <p:nvSpPr>
+          <p:cNvPr id="4" name="TextBox 3"/>
           <p:cNvSpPr txBox="1"/>
           <p:nvPr/>
         </p:nvSpPr>
         <p:spPr>
           <a:xfrm>
-            <a:off x="822960" y="4480560"/>
+            <a:off x="822960" y="1737360"/>
             <a:ext cx="10607040" cy="4206240"/>
           </a:xfrm>
           <a:prstGeom prst="rect">
@@ -5774,13 +5951,13 @@
               </a:spcAft>
             </a:pPr>
             <a:r>
-              <a:rPr sz="1500" b="1">
-                <a:solidFill>
-                  <a:srgbClr val="C1543A"/>
+              <a:rPr sz="1700" b="1">
+                <a:solidFill>
+                  <a:srgbClr val="1B1B1B"/>
                 </a:solidFill>
                 <a:latin typeface="Calibri"/>
               </a:rPr>
-              <a:t>Known weakness, stated up front: at the decoding layer a simple top-2 margin statistic gets 86% of the signal for a fraction of the storage.</a:t>
+              <a:t>Every report is cryptographically signed and bound to the exact data it came from.</a:t>
             </a:r>
           </a:p>
           <a:p>
@@ -5790,13 +5967,84 @@
               </a:spcAft>
             </a:pPr>
             <a:r>
-              <a:rPr sz="1500" b="0">
+              <a:rPr sz="1700" b="0">
                 <a:solidFill>
                   <a:srgbClr val="1B1B1B"/>
                 </a:solidFill>
                 <a:latin typeface="Calibri"/>
               </a:rPr>
-              <a:t>What survives is coverage. It sees changes the cheap statistic is structurally blind to. Slide 12 has the evidence.</a:t>
+              <a:t>Change the report, or the data underneath it, and verification fails.</a:t>
+            </a:r>
+          </a:p>
+          <a:p>
+            <a:pPr>
+              <a:spcAft>
+                <a:spcPts val="1200"/>
+              </a:spcAft>
+            </a:pPr>
+            <a:r>
+              <a:rPr sz="1700" b="1">
+                <a:solidFill>
+                  <a:srgbClr val="0B6E4F"/>
+                </a:solidFill>
+                <a:latin typeface="Calibri"/>
+              </a:rPr>
+              <a:t>The verifier uses the Python standard library and `cryptography`. It does not import the SDK or the harness.</a:t>
+            </a:r>
+          </a:p>
+          <a:p>
+            <a:pPr>
+              <a:spcAft>
+                <a:spcPts val="1200"/>
+              </a:spcAft>
+            </a:pPr>
+            <a:r>
+              <a:rPr sz="1700" b="0">
+                <a:solidFill>
+                  <a:srgbClr val="1B1B1B"/>
+                </a:solidFill>
+                <a:latin typeface="Calibri"/>
+              </a:rPr>
+              <a:t>A standard whose verification requires the vendor's code is not a standard.</a:t>
+            </a:r>
+          </a:p>
+        </p:txBody>
+      </p:sp>
+      <p:sp>
+        <p:nvSpPr>
+          <p:cNvPr id="5" name="TextBox 4"/>
+          <p:cNvSpPr txBox="1"/>
+          <p:nvPr/>
+        </p:nvSpPr>
+        <p:spPr>
+          <a:xfrm>
+            <a:off x="640080" y="5120640"/>
+            <a:ext cx="10972800" cy="548640"/>
+          </a:xfrm>
+          <a:prstGeom prst="rect">
+            <a:avLst/>
+          </a:prstGeom>
+          <a:noFill/>
+        </p:spPr>
+        <p:txBody>
+          <a:bodyPr wrap="square">
+            <a:spAutoFit/>
+          </a:bodyPr>
+          <a:lstStyle/>
+          <a:p>
+            <a:pPr algn="l">
+              <a:spcAft>
+                <a:spcPts val="600"/>
+              </a:spcAft>
+            </a:pPr>
+            <a:r>
+              <a:rPr sz="1400" b="0">
+                <a:solidFill>
+                  <a:srgbClr val="0B6E4F"/>
+                </a:solidFill>
+                <a:latin typeface="Calibri"/>
+              </a:rPr>
+              <a:t>python verify_report.py harness_effect.json --expect-key &lt;key&gt;   -&gt;   ALL CHECKS PASSED</a:t>
             </a:r>
           </a:p>
         </p:txBody>

</xml_diff>

<commit_message>
Remove ARI-E (harness effect)
ARI-E is outside the v0.2 scope, and the ARI-E results on main could not
be reproduced: the dataset revision was not pinned, and the committed
trajectory sample has no eligible cases. The pinned v0.1 spec and rerun
are archived at tag arie-v0.1-f967cba3.

Delete ari/harness.py, experiments/harness-effect/,
experiments/harness-power/ and their tests. Drop the ARI-E rows from the
README, harness guide, findings, experiment index and scope record, and
the ARI-E slides from the deck builder; regenerate the two decks.
Use neutral labels in the attestation tests.

Co-Authored-By: Claude Opus 5.5 <noreply@anthropic.com>
</commit_message>
<xml_diff>
--- a/docs/deck/ari-overview.pptx
+++ b/docs/deck/ari-overview.pptx
@@ -12,8 +12,6 @@
     <p:sldId id="260" r:id="rId11"/>
     <p:sldId id="261" r:id="rId12"/>
     <p:sldId id="262" r:id="rId13"/>
-    <p:sldId id="263" r:id="rId14"/>
-    <p:sldId id="264" r:id="rId15"/>
   </p:sldIdLst>
   <p:sldSz cx="12191695" cy="6858000" type="screen4x3"/>
   <p:notesSz cx="6858000" cy="9144000"/>
@@ -3169,7 +3167,7 @@
                 </a:solidFill>
                 <a:latin typeface="Calibri"/>
               </a:rPr>
-              <a:t>ARI: three indices for agent reproducibility</a:t>
+              <a:t>ARI: two indices for agent reproducibility</a:t>
             </a:r>
           </a:p>
         </p:txBody>
@@ -3542,7 +3540,7 @@
                 </a:solidFill>
                 <a:latin typeface="Calibri"/>
               </a:rPr>
-              <a:t>Three layers, three different questions</a:t>
+              <a:t>Two layers, two different questions</a:t>
             </a:r>
           </a:p>
         </p:txBody>
@@ -3557,7 +3555,7 @@
         </p:nvGraphicFramePr>
         <p:xfrm>
           <a:off x="822960" y="1920240"/>
-          <a:ext cx="10515600" cy="2743200"/>
+          <a:ext cx="10515600" cy="2057400"/>
         </p:xfrm>
         <a:graphic>
           <a:graphicData uri="http://schemas.openxmlformats.org/drawingml/2006/table">
@@ -3720,56 +3718,6 @@
                   <a:tcPr/>
                 </a:tc>
               </a:tr>
-              <a:tr h="685800">
-                <a:tc>
-                  <a:txBody>
-                    <a:bodyPr/>
-                    <a:lstStyle/>
-                    <a:p>
-                      <a:pPr algn="l"/>
-                      <a:r>
-                        <a:rPr sz="1500" b="0">
-                          <a:latin typeface="Calibri"/>
-                        </a:rPr>
-                        <a:t>ARI-E</a:t>
-                      </a:r>
-                    </a:p>
-                  </a:txBody>
-                  <a:tcPr/>
-                </a:tc>
-                <a:tc>
-                  <a:txBody>
-                    <a:bodyPr/>
-                    <a:lstStyle/>
-                    <a:p>
-                      <a:pPr algn="r"/>
-                      <a:r>
-                        <a:rPr sz="1500" b="0">
-                          <a:latin typeface="Calibri"/>
-                        </a:rPr>
-                        <a:t>Does the scaffold or the model decide the outcome?</a:t>
-                      </a:r>
-                    </a:p>
-                  </a:txBody>
-                  <a:tcPr/>
-                </a:tc>
-                <a:tc>
-                  <a:txBody>
-                    <a:bodyPr/>
-                    <a:lstStyle/>
-                    <a:p>
-                      <a:pPr algn="r"/>
-                      <a:r>
-                        <a:rPr sz="1500" b="0">
-                          <a:latin typeface="Calibri"/>
-                        </a:rPr>
-                        <a:t>Anyone publishing agent benchmarks</a:t>
-                      </a:r>
-                    </a:p>
-                  </a:txBody>
-                  <a:tcPr/>
-                </a:tc>
-              </a:tr>
             </a:tbl>
           </a:graphicData>
         </a:graphic>
@@ -3808,7 +3756,7 @@
                 </a:solidFill>
                 <a:latin typeface="Calibri"/>
               </a:rPr>
-              <a:t>Why three and not one: an index called 'agent reproducibility' that only measures embeddings overstates what it covers.</a:t>
+              <a:t>Why two and not one: an index that only measures embeddings overstates what it covers.</a:t>
             </a:r>
           </a:p>
           <a:p>
@@ -4599,7 +4547,7 @@
                 </a:solidFill>
                 <a:latin typeface="Calibri"/>
               </a:rPr>
-              <a:t>USE CASE 3</a:t>
+              <a:t>WHY IT IS CREDIBLE</a:t>
             </a:r>
           </a:p>
         </p:txBody>
@@ -4638,7 +4586,7 @@
                 </a:solidFill>
                 <a:latin typeface="Calibri"/>
               </a:rPr>
-              <a:t>ARI-E: was it the model, or the wrapper?</a:t>
+              <a:t>Anyone can check our numbers without trusting us</a:t>
             </a:r>
           </a:p>
         </p:txBody>
@@ -4651,7 +4599,7 @@
         </p:nvSpPr>
         <p:spPr>
           <a:xfrm>
-            <a:off x="822960" y="1645920"/>
+            <a:off x="822960" y="1737360"/>
             <a:ext cx="10607040" cy="4206240"/>
           </a:xfrm>
           <a:prstGeom prst="rect">
@@ -4677,7 +4625,7 @@
                 </a:solidFill>
                 <a:latin typeface="Calibri"/>
               </a:rPr>
-              <a:t>Two agent products run the identical model. One scores higher. Which one did the work?</a:t>
+              <a:t>Every report is cryptographically signed and bound to the exact data it came from.</a:t>
             </a:r>
           </a:p>
           <a:p>
@@ -4693,154 +4641,52 @@
                 </a:solidFill>
                 <a:latin typeface="Calibri"/>
               </a:rPr>
-              <a:t>Measured on 22,000 real agent runs across two widely used scaffolds.</a:t>
-            </a:r>
-          </a:p>
-        </p:txBody>
-      </p:sp>
-      <p:graphicFrame>
-        <p:nvGraphicFramePr>
-          <p:cNvPr id="5" name="Table 4"/>
-          <p:cNvGraphicFramePr>
-            <a:graphicFrameLocks noGrp="1"/>
-          </p:cNvGraphicFramePr>
-          <p:nvPr/>
-        </p:nvGraphicFramePr>
-        <p:xfrm>
-          <a:off x="822960" y="2926080"/>
-          <a:ext cx="10515600" cy="1920240"/>
-        </p:xfrm>
-        <a:graphic>
-          <a:graphicData uri="http://schemas.openxmlformats.org/drawingml/2006/table">
-            <a:tbl>
-              <a:tblPr firstRow="1" bandRow="1">
-                <a:tableStyleId>{5C22544A-7EE6-4342-B048-85BDC9FD1C3A}</a:tableStyleId>
-              </a:tblPr>
-              <a:tblGrid>
-                <a:gridCol w="5257800"/>
-                <a:gridCol w="5257800"/>
-              </a:tblGrid>
-              <a:tr h="640080">
-                <a:tc>
-                  <a:txBody>
-                    <a:bodyPr/>
-                    <a:lstStyle/>
-                    <a:p>
-                      <a:pPr algn="l"/>
-                      <a:r>
-                        <a:rPr sz="1600" b="1">
-                          <a:latin typeface="Calibri"/>
-                        </a:rPr>
-                        <a:t>What changed</a:t>
-                      </a:r>
-                    </a:p>
-                  </a:txBody>
-                  <a:tcPr/>
-                </a:tc>
-                <a:tc>
-                  <a:txBody>
-                    <a:bodyPr/>
-                    <a:lstStyle/>
-                    <a:p>
-                      <a:pPr algn="r"/>
-                      <a:r>
-                        <a:rPr sz="1600" b="1">
-                          <a:latin typeface="Calibri"/>
-                        </a:rPr>
-                        <a:t>How much it decided the outcome</a:t>
-                      </a:r>
-                    </a:p>
-                  </a:txBody>
-                  <a:tcPr/>
-                </a:tc>
-              </a:tr>
-              <a:tr h="640080">
-                <a:tc>
-                  <a:txBody>
-                    <a:bodyPr/>
-                    <a:lstStyle/>
-                    <a:p>
-                      <a:pPr algn="l"/>
-                      <a:r>
-                        <a:rPr sz="1600" b="0">
-                          <a:solidFill>
-                            <a:srgbClr val="0B6E4F"/>
-                          </a:solidFill>
-                          <a:latin typeface="Calibri"/>
-                        </a:rPr>
-                        <a:t>The scaffold around the model</a:t>
-                      </a:r>
-                    </a:p>
-                  </a:txBody>
-                  <a:tcPr/>
-                </a:tc>
-                <a:tc>
-                  <a:txBody>
-                    <a:bodyPr/>
-                    <a:lstStyle/>
-                    <a:p>
-                      <a:pPr algn="r"/>
-                      <a:r>
-                        <a:rPr sz="1600" b="0">
-                          <a:solidFill>
-                            <a:srgbClr val="0B6E4F"/>
-                          </a:solidFill>
-                          <a:latin typeface="Calibri"/>
-                        </a:rPr>
-                        <a:t>+0.069</a:t>
-                      </a:r>
-                    </a:p>
-                  </a:txBody>
-                  <a:tcPr/>
-                </a:tc>
-              </a:tr>
-              <a:tr h="640080">
-                <a:tc>
-                  <a:txBody>
-                    <a:bodyPr/>
-                    <a:lstStyle/>
-                    <a:p>
-                      <a:pPr algn="l"/>
-                      <a:r>
-                        <a:rPr sz="1600" b="0">
-                          <a:latin typeface="Calibri"/>
-                        </a:rPr>
-                        <a:t>The model itself</a:t>
-                      </a:r>
-                    </a:p>
-                  </a:txBody>
-                  <a:tcPr/>
-                </a:tc>
-                <a:tc>
-                  <a:txBody>
-                    <a:bodyPr/>
-                    <a:lstStyle/>
-                    <a:p>
-                      <a:pPr algn="r"/>
-                      <a:r>
-                        <a:rPr sz="1600" b="0">
-                          <a:latin typeface="Calibri"/>
-                        </a:rPr>
-                        <a:t>+0.050</a:t>
-                      </a:r>
-                    </a:p>
-                  </a:txBody>
-                  <a:tcPr/>
-                </a:tc>
-              </a:tr>
-            </a:tbl>
-          </a:graphicData>
-        </a:graphic>
-      </p:graphicFrame>
-      <p:sp>
-        <p:nvSpPr>
-          <p:cNvPr id="6" name="TextBox 5"/>
+              <a:t>Change the report, or the data underneath it, and verification fails.</a:t>
+            </a:r>
+          </a:p>
+          <a:p>
+            <a:pPr>
+              <a:spcAft>
+                <a:spcPts val="1200"/>
+              </a:spcAft>
+            </a:pPr>
+            <a:r>
+              <a:rPr sz="1700" b="1">
+                <a:solidFill>
+                  <a:srgbClr val="0B6E4F"/>
+                </a:solidFill>
+                <a:latin typeface="Calibri"/>
+              </a:rPr>
+              <a:t>The verifier is 175 lines and does not use our software.</a:t>
+            </a:r>
+          </a:p>
+          <a:p>
+            <a:pPr>
+              <a:spcAft>
+                <a:spcPts val="1200"/>
+              </a:spcAft>
+            </a:pPr>
+            <a:r>
+              <a:rPr sz="1700" b="0">
+                <a:solidFill>
+                  <a:srgbClr val="1B1B1B"/>
+                </a:solidFill>
+                <a:latin typeface="Calibri"/>
+              </a:rPr>
+              <a:t>A standard whose verification requires the vendor's code is not a standard.</a:t>
+            </a:r>
+          </a:p>
+        </p:txBody>
+      </p:sp>
+      <p:sp>
+        <p:nvSpPr>
+          <p:cNvPr id="5" name="TextBox 4"/>
           <p:cNvSpPr txBox="1"/>
           <p:nvPr/>
         </p:nvSpPr>
         <p:spPr>
           <a:xfrm>
-            <a:off x="640080" y="4937760"/>
+            <a:off x="640080" y="5120640"/>
             <a:ext cx="10972800" cy="548640"/>
           </a:xfrm>
           <a:prstGeom prst="rect">
@@ -4860,13 +4706,13 @@
               </a:spcAft>
             </a:pPr>
             <a:r>
-              <a:rPr sz="1500" b="0">
-                <a:solidFill>
-                  <a:srgbClr val="1B1B1B"/>
+              <a:rPr sz="1400" b="0">
+                <a:solidFill>
+                  <a:srgbClr val="0B6E4F"/>
                 </a:solidFill>
                 <a:latin typeface="Calibri"/>
               </a:rPr>
-              <a:t>The wrapper mattered more than the model. Benchmark tables that name only the model are not comparable.</a:t>
+              <a:t>python verify_report.py regime_matrix.json --expect-key &lt;key&gt;   -&gt;   ALL CHECKS PASSED</a:t>
             </a:r>
           </a:p>
         </p:txBody>
@@ -4923,7 +4769,7 @@
                 </a:solidFill>
                 <a:latin typeface="Calibri"/>
               </a:rPr>
-              <a:t>WHY THIS IS HARD TO COPY</a:t>
+              <a:t>HONEST STATUS</a:t>
             </a:r>
           </a:p>
         </p:txBody>
@@ -4962,558 +4808,6 @@
                 </a:solidFill>
                 <a:latin typeface="Calibri"/>
               </a:rPr>
-              <a:t>The control is the product</a:t>
-            </a:r>
-          </a:p>
-        </p:txBody>
-      </p:sp>
-      <p:sp>
-        <p:nvSpPr>
-          <p:cNvPr id="4" name="TextBox 3"/>
-          <p:cNvSpPr txBox="1"/>
-          <p:nvPr/>
-        </p:nvSpPr>
-        <p:spPr>
-          <a:xfrm>
-            <a:off x="822960" y="1645920"/>
-            <a:ext cx="10607040" cy="4206240"/>
-          </a:xfrm>
-          <a:prstGeom prst="rect">
-            <a:avLst/>
-          </a:prstGeom>
-          <a:noFill/>
-        </p:spPr>
-        <p:txBody>
-          <a:bodyPr wrap="square">
-            <a:spAutoFit/>
-          </a:bodyPr>
-          <a:lstStyle/>
-          <a:p>
-            <a:pPr>
-              <a:spcAft>
-                <a:spcPts val="1200"/>
-              </a:spcAft>
-            </a:pPr>
-            <a:r>
-              <a:rPr sz="1700" b="1">
-                <a:solidFill>
-                  <a:srgbClr val="1B1B1B"/>
-                </a:solidFill>
-                <a:latin typeface="Calibri"/>
-              </a:rPr>
-              <a:t>Agents disagree with themselves 10-13% of the time. Anyone can diff two systems. Almost nobody subtracts that noise.</a:t>
-            </a:r>
-          </a:p>
-          <a:p>
-            <a:pPr>
-              <a:spcAft>
-                <a:spcPts val="1200"/>
-              </a:spcAft>
-            </a:pPr>
-            <a:r>
-              <a:rPr sz="1700" b="0">
-                <a:solidFill>
-                  <a:srgbClr val="1B1B1B"/>
-                </a:solidFill>
-                <a:latin typeface="Calibri"/>
-              </a:rPr>
-              <a:t/>
-            </a:r>
-          </a:p>
-        </p:txBody>
-      </p:sp>
-      <p:graphicFrame>
-        <p:nvGraphicFramePr>
-          <p:cNvPr id="5" name="Table 4"/>
-          <p:cNvGraphicFramePr>
-            <a:graphicFrameLocks noGrp="1"/>
-          </p:cNvGraphicFramePr>
-          <p:nvPr/>
-        </p:nvGraphicFramePr>
-        <p:xfrm>
-          <a:off x="822960" y="2743200"/>
-          <a:ext cx="10515600" cy="1920240"/>
-        </p:xfrm>
-        <a:graphic>
-          <a:graphicData uri="http://schemas.openxmlformats.org/drawingml/2006/table">
-            <a:tbl>
-              <a:tblPr firstRow="1" bandRow="1">
-                <a:tableStyleId>{5C22544A-7EE6-4342-B048-85BDC9FD1C3A}</a:tableStyleId>
-              </a:tblPr>
-              <a:tblGrid>
-                <a:gridCol w="5257800"/>
-                <a:gridCol w="5257800"/>
-              </a:tblGrid>
-              <a:tr h="640080">
-                <a:tc>
-                  <a:txBody>
-                    <a:bodyPr/>
-                    <a:lstStyle/>
-                    <a:p>
-                      <a:pPr algn="l"/>
-                      <a:r>
-                        <a:rPr sz="1600" b="1">
-                          <a:latin typeface="Calibri"/>
-                        </a:rPr>
-                        <a:t>Method</a:t>
-                      </a:r>
-                    </a:p>
-                  </a:txBody>
-                  <a:tcPr/>
-                </a:tc>
-                <a:tc>
-                  <a:txBody>
-                    <a:bodyPr/>
-                    <a:lstStyle/>
-                    <a:p>
-                      <a:pPr algn="r"/>
-                      <a:r>
-                        <a:rPr sz="1600" b="1">
-                          <a:latin typeface="Calibri"/>
-                        </a:rPr>
-                        <a:t>Reported effect</a:t>
-                      </a:r>
-                    </a:p>
-                  </a:txBody>
-                  <a:tcPr/>
-                </a:tc>
-              </a:tr>
-              <a:tr h="640080">
-                <a:tc>
-                  <a:txBody>
-                    <a:bodyPr/>
-                    <a:lstStyle/>
-                    <a:p>
-                      <a:pPr algn="l"/>
-                      <a:r>
-                        <a:rPr sz="1600" b="0">
-                          <a:solidFill>
-                            <a:srgbClr val="C1543A"/>
-                          </a:solidFill>
-                          <a:latin typeface="Calibri"/>
-                        </a:rPr>
-                        <a:t>Naive difference between the two scaffolds</a:t>
-                      </a:r>
-                    </a:p>
-                  </a:txBody>
-                  <a:tcPr/>
-                </a:tc>
-                <a:tc>
-                  <a:txBody>
-                    <a:bodyPr/>
-                    <a:lstStyle/>
-                    <a:p>
-                      <a:pPr algn="r"/>
-                      <a:r>
-                        <a:rPr sz="1600" b="0">
-                          <a:solidFill>
-                            <a:srgbClr val="C1543A"/>
-                          </a:solidFill>
-                          <a:latin typeface="Calibri"/>
-                        </a:rPr>
-                        <a:t>21.5%</a:t>
-                      </a:r>
-                    </a:p>
-                  </a:txBody>
-                  <a:tcPr/>
-                </a:tc>
-              </a:tr>
-              <a:tr h="640080">
-                <a:tc>
-                  <a:txBody>
-                    <a:bodyPr/>
-                    <a:lstStyle/>
-                    <a:p>
-                      <a:pPr algn="l"/>
-                      <a:r>
-                        <a:rPr sz="1600" b="0">
-                          <a:solidFill>
-                            <a:srgbClr val="0B6E4F"/>
-                          </a:solidFill>
-                          <a:latin typeface="Calibri"/>
-                        </a:rPr>
-                        <a:t>ARI-E, after removing the agent's own noise</a:t>
-                      </a:r>
-                    </a:p>
-                  </a:txBody>
-                  <a:tcPr/>
-                </a:tc>
-                <a:tc>
-                  <a:txBody>
-                    <a:bodyPr/>
-                    <a:lstStyle/>
-                    <a:p>
-                      <a:pPr algn="r"/>
-                      <a:r>
-                        <a:rPr sz="1600" b="0">
-                          <a:solidFill>
-                            <a:srgbClr val="0B6E4F"/>
-                          </a:solidFill>
-                          <a:latin typeface="Calibri"/>
-                        </a:rPr>
-                        <a:t>8.9%</a:t>
-                      </a:r>
-                    </a:p>
-                  </a:txBody>
-                  <a:tcPr/>
-                </a:tc>
-              </a:tr>
-            </a:tbl>
-          </a:graphicData>
-        </a:graphic>
-      </p:graphicFrame>
-      <p:sp>
-        <p:nvSpPr>
-          <p:cNvPr id="6" name="TextBox 5"/>
-          <p:cNvSpPr txBox="1"/>
-          <p:nvPr/>
-        </p:nvSpPr>
-        <p:spPr>
-          <a:xfrm>
-            <a:off x="640080" y="4754880"/>
-            <a:ext cx="10972800" cy="548640"/>
-          </a:xfrm>
-          <a:prstGeom prst="rect">
-            <a:avLst/>
-          </a:prstGeom>
-          <a:noFill/>
-        </p:spPr>
-        <p:txBody>
-          <a:bodyPr wrap="square">
-            <a:spAutoFit/>
-          </a:bodyPr>
-          <a:lstStyle/>
-          <a:p>
-            <a:pPr algn="l">
-              <a:spcAft>
-                <a:spcPts val="600"/>
-              </a:spcAft>
-            </a:pPr>
-            <a:r>
-              <a:rPr sz="1500" b="0">
-                <a:solidFill>
-                  <a:srgbClr val="1B1B1B"/>
-                </a:solidFill>
-                <a:latin typeface="Calibri"/>
-              </a:rPr>
-              <a:t>The naive number is 2.4x too large. Across every comparison we ran, the control removed 59-74% of the apparent effect. A competitor without it reports noise as signal.</a:t>
-            </a:r>
-          </a:p>
-        </p:txBody>
-      </p:sp>
-    </p:spTree>
-  </p:cSld>
-  <p:clrMapOvr>
-    <a:masterClrMapping/>
-  </p:clrMapOvr>
-</p:sld>
-</file>
-
-<file path=ppt/slides/slide8.xml><?xml version="1.0" encoding="utf-8"?>
-<p:sld xmlns:a="http://schemas.openxmlformats.org/drawingml/2006/main" xmlns:p="http://schemas.openxmlformats.org/presentationml/2006/main" xmlns:r="http://schemas.openxmlformats.org/officeDocument/2006/relationships">
-  <p:cSld>
-    <p:spTree>
-      <p:nvGrpSpPr>
-        <p:cNvPr id="1" name=""/>
-        <p:cNvGrpSpPr/>
-        <p:nvPr/>
-      </p:nvGrpSpPr>
-      <p:grpSpPr/>
-      <p:sp>
-        <p:nvSpPr>
-          <p:cNvPr id="2" name="TextBox 1"/>
-          <p:cNvSpPr txBox="1"/>
-          <p:nvPr/>
-        </p:nvSpPr>
-        <p:spPr>
-          <a:xfrm>
-            <a:off x="640080" y="320040"/>
-            <a:ext cx="10972800" cy="320040"/>
-          </a:xfrm>
-          <a:prstGeom prst="rect">
-            <a:avLst/>
-          </a:prstGeom>
-          <a:noFill/>
-        </p:spPr>
-        <p:txBody>
-          <a:bodyPr wrap="square">
-            <a:spAutoFit/>
-          </a:bodyPr>
-          <a:lstStyle/>
-          <a:p>
-            <a:pPr algn="l">
-              <a:spcAft>
-                <a:spcPts val="600"/>
-              </a:spcAft>
-            </a:pPr>
-            <a:r>
-              <a:rPr sz="1200" b="0">
-                <a:solidFill>
-                  <a:srgbClr val="6E6E6E"/>
-                </a:solidFill>
-                <a:latin typeface="Calibri"/>
-              </a:rPr>
-              <a:t>WHY IT IS CREDIBLE</a:t>
-            </a:r>
-          </a:p>
-        </p:txBody>
-      </p:sp>
-      <p:sp>
-        <p:nvSpPr>
-          <p:cNvPr id="3" name="TextBox 2"/>
-          <p:cNvSpPr txBox="1"/>
-          <p:nvPr/>
-        </p:nvSpPr>
-        <p:spPr>
-          <a:xfrm>
-            <a:off x="640080" y="640080"/>
-            <a:ext cx="10972800" cy="822960"/>
-          </a:xfrm>
-          <a:prstGeom prst="rect">
-            <a:avLst/>
-          </a:prstGeom>
-          <a:noFill/>
-        </p:spPr>
-        <p:txBody>
-          <a:bodyPr wrap="square">
-            <a:spAutoFit/>
-          </a:bodyPr>
-          <a:lstStyle/>
-          <a:p>
-            <a:pPr algn="l">
-              <a:spcAft>
-                <a:spcPts val="600"/>
-              </a:spcAft>
-            </a:pPr>
-            <a:r>
-              <a:rPr sz="2800" b="1">
-                <a:solidFill>
-                  <a:srgbClr val="1B1B1B"/>
-                </a:solidFill>
-                <a:latin typeface="Calibri"/>
-              </a:rPr>
-              <a:t>Anyone can check our numbers without trusting us</a:t>
-            </a:r>
-          </a:p>
-        </p:txBody>
-      </p:sp>
-      <p:sp>
-        <p:nvSpPr>
-          <p:cNvPr id="4" name="TextBox 3"/>
-          <p:cNvSpPr txBox="1"/>
-          <p:nvPr/>
-        </p:nvSpPr>
-        <p:spPr>
-          <a:xfrm>
-            <a:off x="822960" y="1737360"/>
-            <a:ext cx="10607040" cy="4206240"/>
-          </a:xfrm>
-          <a:prstGeom prst="rect">
-            <a:avLst/>
-          </a:prstGeom>
-          <a:noFill/>
-        </p:spPr>
-        <p:txBody>
-          <a:bodyPr wrap="square">
-            <a:spAutoFit/>
-          </a:bodyPr>
-          <a:lstStyle/>
-          <a:p>
-            <a:pPr>
-              <a:spcAft>
-                <a:spcPts val="1200"/>
-              </a:spcAft>
-            </a:pPr>
-            <a:r>
-              <a:rPr sz="1700" b="1">
-                <a:solidFill>
-                  <a:srgbClr val="1B1B1B"/>
-                </a:solidFill>
-                <a:latin typeface="Calibri"/>
-              </a:rPr>
-              <a:t>Every report is cryptographically signed and bound to the exact data it came from.</a:t>
-            </a:r>
-          </a:p>
-          <a:p>
-            <a:pPr>
-              <a:spcAft>
-                <a:spcPts val="1200"/>
-              </a:spcAft>
-            </a:pPr>
-            <a:r>
-              <a:rPr sz="1700" b="0">
-                <a:solidFill>
-                  <a:srgbClr val="1B1B1B"/>
-                </a:solidFill>
-                <a:latin typeface="Calibri"/>
-              </a:rPr>
-              <a:t>Change the report, or the data underneath it, and verification fails.</a:t>
-            </a:r>
-          </a:p>
-          <a:p>
-            <a:pPr>
-              <a:spcAft>
-                <a:spcPts val="1200"/>
-              </a:spcAft>
-            </a:pPr>
-            <a:r>
-              <a:rPr sz="1700" b="1">
-                <a:solidFill>
-                  <a:srgbClr val="0B6E4F"/>
-                </a:solidFill>
-                <a:latin typeface="Calibri"/>
-              </a:rPr>
-              <a:t>The verifier is 175 lines and does not use our software.</a:t>
-            </a:r>
-          </a:p>
-          <a:p>
-            <a:pPr>
-              <a:spcAft>
-                <a:spcPts val="1200"/>
-              </a:spcAft>
-            </a:pPr>
-            <a:r>
-              <a:rPr sz="1700" b="0">
-                <a:solidFill>
-                  <a:srgbClr val="1B1B1B"/>
-                </a:solidFill>
-                <a:latin typeface="Calibri"/>
-              </a:rPr>
-              <a:t>A standard whose verification requires the vendor's code is not a standard.</a:t>
-            </a:r>
-          </a:p>
-        </p:txBody>
-      </p:sp>
-      <p:sp>
-        <p:nvSpPr>
-          <p:cNvPr id="5" name="TextBox 4"/>
-          <p:cNvSpPr txBox="1"/>
-          <p:nvPr/>
-        </p:nvSpPr>
-        <p:spPr>
-          <a:xfrm>
-            <a:off x="640080" y="5120640"/>
-            <a:ext cx="10972800" cy="548640"/>
-          </a:xfrm>
-          <a:prstGeom prst="rect">
-            <a:avLst/>
-          </a:prstGeom>
-          <a:noFill/>
-        </p:spPr>
-        <p:txBody>
-          <a:bodyPr wrap="square">
-            <a:spAutoFit/>
-          </a:bodyPr>
-          <a:lstStyle/>
-          <a:p>
-            <a:pPr algn="l">
-              <a:spcAft>
-                <a:spcPts val="600"/>
-              </a:spcAft>
-            </a:pPr>
-            <a:r>
-              <a:rPr sz="1400" b="0">
-                <a:solidFill>
-                  <a:srgbClr val="0B6E4F"/>
-                </a:solidFill>
-                <a:latin typeface="Calibri"/>
-              </a:rPr>
-              <a:t>python verify_report.py harness_effect.json --expect-key &lt;key&gt;   -&gt;   ALL CHECKS PASSED</a:t>
-            </a:r>
-          </a:p>
-        </p:txBody>
-      </p:sp>
-    </p:spTree>
-  </p:cSld>
-  <p:clrMapOvr>
-    <a:masterClrMapping/>
-  </p:clrMapOvr>
-</p:sld>
-</file>
-
-<file path=ppt/slides/slide9.xml><?xml version="1.0" encoding="utf-8"?>
-<p:sld xmlns:a="http://schemas.openxmlformats.org/drawingml/2006/main" xmlns:p="http://schemas.openxmlformats.org/presentationml/2006/main" xmlns:r="http://schemas.openxmlformats.org/officeDocument/2006/relationships">
-  <p:cSld>
-    <p:spTree>
-      <p:nvGrpSpPr>
-        <p:cNvPr id="1" name=""/>
-        <p:cNvGrpSpPr/>
-        <p:nvPr/>
-      </p:nvGrpSpPr>
-      <p:grpSpPr/>
-      <p:sp>
-        <p:nvSpPr>
-          <p:cNvPr id="2" name="TextBox 1"/>
-          <p:cNvSpPr txBox="1"/>
-          <p:nvPr/>
-        </p:nvSpPr>
-        <p:spPr>
-          <a:xfrm>
-            <a:off x="640080" y="320040"/>
-            <a:ext cx="10972800" cy="320040"/>
-          </a:xfrm>
-          <a:prstGeom prst="rect">
-            <a:avLst/>
-          </a:prstGeom>
-          <a:noFill/>
-        </p:spPr>
-        <p:txBody>
-          <a:bodyPr wrap="square">
-            <a:spAutoFit/>
-          </a:bodyPr>
-          <a:lstStyle/>
-          <a:p>
-            <a:pPr algn="l">
-              <a:spcAft>
-                <a:spcPts val="600"/>
-              </a:spcAft>
-            </a:pPr>
-            <a:r>
-              <a:rPr sz="1200" b="0">
-                <a:solidFill>
-                  <a:srgbClr val="6E6E6E"/>
-                </a:solidFill>
-                <a:latin typeface="Calibri"/>
-              </a:rPr>
-              <a:t>HONEST STATUS</a:t>
-            </a:r>
-          </a:p>
-        </p:txBody>
-      </p:sp>
-      <p:sp>
-        <p:nvSpPr>
-          <p:cNvPr id="3" name="TextBox 2"/>
-          <p:cNvSpPr txBox="1"/>
-          <p:nvPr/>
-        </p:nvSpPr>
-        <p:spPr>
-          <a:xfrm>
-            <a:off x="640080" y="640080"/>
-            <a:ext cx="10972800" cy="822960"/>
-          </a:xfrm>
-          <a:prstGeom prst="rect">
-            <a:avLst/>
-          </a:prstGeom>
-          <a:noFill/>
-        </p:spPr>
-        <p:txBody>
-          <a:bodyPr wrap="square">
-            <a:spAutoFit/>
-          </a:bodyPr>
-          <a:lstStyle/>
-          <a:p>
-            <a:pPr algn="l">
-              <a:spcAft>
-                <a:spcPts val="600"/>
-              </a:spcAft>
-            </a:pPr>
-            <a:r>
-              <a:rPr sz="2800" b="1">
-                <a:solidFill>
-                  <a:srgbClr val="1B1B1B"/>
-                </a:solidFill>
-                <a:latin typeface="Calibri"/>
-              </a:rPr>
               <a:t>Where we actually are</a:t>
             </a:r>
           </a:p>
@@ -5529,7 +4823,7 @@
         </p:nvGraphicFramePr>
         <p:xfrm>
           <a:off x="822960" y="1828800"/>
-          <a:ext cx="10515600" cy="2743200"/>
+          <a:ext cx="10515600" cy="2057400"/>
         </p:xfrm>
         <a:graphic>
           <a:graphicData uri="http://schemas.openxmlformats.org/drawingml/2006/table">
@@ -5692,56 +4986,6 @@
                   <a:tcPr/>
                 </a:tc>
               </a:tr>
-              <a:tr h="685800">
-                <a:tc>
-                  <a:txBody>
-                    <a:bodyPr/>
-                    <a:lstStyle/>
-                    <a:p>
-                      <a:pPr algn="l"/>
-                      <a:r>
-                        <a:rPr sz="1500" b="0">
-                          <a:latin typeface="Calibri"/>
-                        </a:rPr>
-                        <a:t>ARI-E</a:t>
-                      </a:r>
-                    </a:p>
-                  </a:txBody>
-                  <a:tcPr/>
-                </a:tc>
-                <a:tc>
-                  <a:txBody>
-                    <a:bodyPr/>
-                    <a:lstStyle/>
-                    <a:p>
-                      <a:pPr algn="r"/>
-                      <a:r>
-                        <a:rPr sz="1500" b="0">
-                          <a:latin typeface="Calibri"/>
-                        </a:rPr>
-                        <a:t>22,000 real agent runs</a:t>
-                      </a:r>
-                    </a:p>
-                  </a:txBody>
-                  <a:tcPr/>
-                </a:tc>
-                <a:tc>
-                  <a:txBody>
-                    <a:bodyPr/>
-                    <a:lstStyle/>
-                    <a:p>
-                      <a:pPr algn="r"/>
-                      <a:r>
-                        <a:rPr sz="1500" b="0">
-                          <a:latin typeface="Calibri"/>
-                        </a:rPr>
-                        <a:t>Strong. Largest effect of the three</a:t>
-                      </a:r>
-                    </a:p>
-                  </a:txBody>
-                  <a:tcPr/>
-                </a:tc>
-              </a:tr>
             </a:tbl>
           </a:graphicData>
         </a:graphic>
@@ -5796,7 +5040,7 @@
                 </a:solidFill>
                 <a:latin typeface="Calibri"/>
               </a:rPr>
-              <a:t>What survives is coverage. It sees changes the cheap statistic is structurally blind to. Slide 12 has the evidence.</a:t>
+              <a:t>What survives is coverage. It sees changes the cheap statistic is structurally blind to. The technical deck has the evidence.</a:t>
             </a:r>
           </a:p>
         </p:txBody>

</xml_diff>